<commit_message>
K2 M4: replace paid Claude API Sheets helper with free PDF-export Apps Script; add Claude-role framing + install steps
</commit_message>
<xml_diff>
--- a/K2-Produktivitas/M04-Google-Sheets/K2-M04-Google-Sheets.pptx
+++ b/K2-Produktivitas/M04-Google-Sheets/K2-M04-Google-Sheets.pptx
@@ -4320,7 +4320,7 @@
         <p:spPr>
           <a:xfrm>
             <a:off x="548640" y="5390642"/>
-            <a:ext cx="11094415" cy="479552"/>
+            <a:ext cx="11094415" cy="719328"/>
           </a:xfrm>
           <a:prstGeom prst="rect">
             <a:avLst/>
@@ -4347,7 +4347,7 @@
                 <a:ea typeface="Helvetica" pitchFamily="34" charset="-122"/>
                 <a:cs typeface="Helvetica" pitchFamily="34" charset="-120"/>
               </a:rPr>
-              <a:t>Claude in Chrome bisa baca &amp; isi formula langsung di Google Sheets tanpa copy-paste — install extension dari Chrome Web Store. Untuk otomatisasi berulang (laporan mingguan, notifikasi stok habis), Claude bisa bantu tulis Google Apps Script.</a:t>
+              <a:t>Claude in Chrome bisa baca &amp; isi formula langsung di Google Sheets tanpa copy-paste — install extension dari Chrome Web Store. Butuh paket Pro atau lebih tinggi (tidak ada di Free). Untuk otomatisasi berulang (laporan mingguan, notifikasi stok habis), Claude bisa bantu tulis Google Apps Script.</a:t>
             </a:r>
             <a:endParaRPr lang="en-US" sz="1250" dirty="0"/>
           </a:p>
@@ -4550,7 +4550,7 @@
                 <a:ea typeface="Helvetica" pitchFamily="34" charset="-122"/>
                 <a:cs typeface="Helvetica" pitchFamily="34" charset="-120"/>
               </a:rPr>
-              <a:t>Bonus: Menu “Claude AI” di Google Sheets</a:t>
+              <a:t>Bonus: Menu “Export PDF” di Google Sheets</a:t>
             </a:r>
             <a:endParaRPr lang="en-US" sz="2200" dirty="0"/>
           </a:p>
@@ -4589,7 +4589,7 @@
                 <a:ea typeface="Helvetica" pitchFamily="34" charset="-122"/>
                 <a:cs typeface="Helvetica" pitchFamily="34" charset="-120"/>
               </a:rPr>
-              <a:t>LEBIH PERMANEN DARI COPY-PASTE</a:t>
+              <a:t>CLAUDE MENULIS AUTOMASINYA, BUKAN CUMA KASIH SCRIPT JADI</a:t>
             </a:r>
             <a:endParaRPr lang="en-US" sz="1250" dirty="0"/>
           </a:p>
@@ -4655,7 +4655,7 @@
                 <a:ea typeface="Helvetica" pitchFamily="34" charset="-122"/>
                 <a:cs typeface="Helvetica" pitchFamily="34" charset="-120"/>
               </a:rPr>
-              <a:t>◆  DOWNLOAD K2-CLAUDE-SHEETS-HELPER.JS</a:t>
+              <a:t>◆  DOWNLOAD K2-PDF-EXPORT-HELPER.JS — 100% GRATIS</a:t>
             </a:r>
             <a:endParaRPr lang="en-US" sz="1250" dirty="0"/>
           </a:p>
@@ -4697,9 +4697,510 @@
                 <a:ea typeface="Helvetica" pitchFamily="34" charset="-122"/>
                 <a:cs typeface="Helvetica" pitchFamily="34" charset="-120"/>
               </a:rPr>
-              <a:t>Sebuah Google Apps Script yang menambahkan menu “Claude AI” ke Sheets-mu: Analisis Data Terpilih, Buat Formula dari Deskripsi, Ringkasan Eksekutif Tabel, Isi Kolom dengan Claude, dan Debug Formula Error. Install lewat Extensions &gt; Apps Script, butuh API key dari console.anthropic.com. Cocok kalau kamu pakai fitur ini rutin tiap minggu.</a:t>
+              <a:t>Google Apps Script yang menambahkan menu “Export PDF” ke Sheets-mu: export sheet aktif atau rentang terpilih jadi PDF rapi, tersimpan otomatis ke Drive. Script ini dibuat dengan cara memprompt Claude langsung — tidak ada API key atau paket Pro yang dibutuhkan, cuma fitur bawaan Google.</a:t>
             </a:r>
             <a:endParaRPr lang="en-US" sz="1250" dirty="0"/>
+          </a:p>
+        </p:txBody>
+      </p:sp>
+      <p:sp>
+        <p:nvSpPr>
+          <p:cNvPr id="11" name="Shape 9"/>
+          <p:cNvSpPr/>
+          <p:nvPr/>
+        </p:nvSpPr>
+        <p:spPr>
+          <a:xfrm>
+            <a:off x="548640" y="3830384"/>
+            <a:ext cx="3527450" cy="1261750"/>
+          </a:xfrm>
+          <a:prstGeom prst="roundRect">
+            <a:avLst>
+              <a:gd name="adj" fmla="val 7247"/>
+            </a:avLst>
+          </a:prstGeom>
+          <a:solidFill>
+            <a:srgbClr val="F3F0FF"/>
+          </a:solidFill>
+          <a:ln w="12700">
+            <a:solidFill>
+              <a:srgbClr val="DCD3FB"/>
+            </a:solidFill>
+            <a:prstDash val="solid"/>
+          </a:ln>
+        </p:spPr>
+      </p:sp>
+      <p:sp>
+        <p:nvSpPr>
+          <p:cNvPr id="12" name="Shape 10"/>
+          <p:cNvSpPr/>
+          <p:nvPr/>
+        </p:nvSpPr>
+        <p:spPr>
+          <a:xfrm>
+            <a:off x="749808" y="4031552"/>
+            <a:ext cx="384048" cy="384048"/>
+          </a:xfrm>
+          <a:prstGeom prst="ellipse">
+            <a:avLst/>
+          </a:prstGeom>
+          <a:solidFill>
+            <a:srgbClr val="6849F6"/>
+          </a:solidFill>
+          <a:ln/>
+        </p:spPr>
+      </p:sp>
+      <p:sp>
+        <p:nvSpPr>
+          <p:cNvPr id="13" name="Text 11"/>
+          <p:cNvSpPr/>
+          <p:nvPr/>
+        </p:nvSpPr>
+        <p:spPr>
+          <a:xfrm>
+            <a:off x="749808" y="4031552"/>
+            <a:ext cx="384048" cy="384048"/>
+          </a:xfrm>
+          <a:prstGeom prst="rect">
+            <a:avLst/>
+          </a:prstGeom>
+          <a:noFill/>
+          <a:ln/>
+        </p:spPr>
+        <p:txBody>
+          <a:bodyPr wrap="square" lIns="0" tIns="0" rIns="0" bIns="0" rtlCol="0" anchor="ctr"/>
+          <a:lstStyle/>
+          <a:p>
+            <a:pPr algn="ctr" indent="0" marL="0">
+              <a:buNone/>
+            </a:pPr>
+            <a:r>
+              <a:rPr lang="en-US" sz="1400" b="1" dirty="0">
+                <a:solidFill>
+                  <a:srgbClr val="FFFFFF"/>
+                </a:solidFill>
+                <a:latin typeface="Helvetica" pitchFamily="34" charset="0"/>
+                <a:ea typeface="Helvetica" pitchFamily="34" charset="-122"/>
+                <a:cs typeface="Helvetica" pitchFamily="34" charset="-120"/>
+              </a:rPr>
+              <a:t>1</a:t>
+            </a:r>
+            <a:endParaRPr lang="en-US" sz="1400" dirty="0"/>
+          </a:p>
+        </p:txBody>
+      </p:sp>
+      <p:sp>
+        <p:nvSpPr>
+          <p:cNvPr id="14" name="Text 12"/>
+          <p:cNvSpPr/>
+          <p:nvPr/>
+        </p:nvSpPr>
+        <p:spPr>
+          <a:xfrm>
+            <a:off x="1271016" y="4013264"/>
+            <a:ext cx="2603906" cy="310896"/>
+          </a:xfrm>
+          <a:prstGeom prst="rect">
+            <a:avLst/>
+          </a:prstGeom>
+          <a:noFill/>
+          <a:ln/>
+        </p:spPr>
+        <p:txBody>
+          <a:bodyPr wrap="square" lIns="0" tIns="0" rIns="0" bIns="0" rtlCol="0" anchor="ctr"/>
+          <a:lstStyle/>
+          <a:p>
+            <a:pPr indent="0" marL="0">
+              <a:buNone/>
+            </a:pPr>
+            <a:r>
+              <a:rPr lang="en-US" sz="1400" b="1" dirty="0">
+                <a:solidFill>
+                  <a:srgbClr val="0D1321"/>
+                </a:solidFill>
+                <a:latin typeface="Helvetica" pitchFamily="34" charset="0"/>
+                <a:ea typeface="Helvetica" pitchFamily="34" charset="-122"/>
+                <a:cs typeface="Helvetica" pitchFamily="34" charset="-120"/>
+              </a:rPr>
+              <a:t>Extensions</a:t>
+            </a:r>
+            <a:endParaRPr lang="en-US" sz="1400" dirty="0"/>
+          </a:p>
+        </p:txBody>
+      </p:sp>
+      <p:sp>
+        <p:nvSpPr>
+          <p:cNvPr id="15" name="Text 13"/>
+          <p:cNvSpPr/>
+          <p:nvPr/>
+        </p:nvSpPr>
+        <p:spPr>
+          <a:xfrm>
+            <a:off x="749808" y="4452176"/>
+            <a:ext cx="3125114" cy="438790"/>
+          </a:xfrm>
+          <a:prstGeom prst="rect">
+            <a:avLst/>
+          </a:prstGeom>
+          <a:noFill/>
+          <a:ln/>
+        </p:spPr>
+        <p:txBody>
+          <a:bodyPr wrap="square" lIns="0" tIns="0" rIns="0" bIns="0" rtlCol="0" anchor="t"/>
+          <a:lstStyle/>
+          <a:p>
+            <a:pPr indent="0" marL="0">
+              <a:lnSpc>
+                <a:spcPct val="122000"/>
+              </a:lnSpc>
+              <a:buNone/>
+            </a:pPr>
+            <a:r>
+              <a:rPr lang="en-US" sz="1200" dirty="0">
+                <a:solidFill>
+                  <a:srgbClr val="23283A"/>
+                </a:solidFill>
+                <a:latin typeface="Helvetica" pitchFamily="34" charset="0"/>
+                <a:ea typeface="Helvetica" pitchFamily="34" charset="-122"/>
+                <a:cs typeface="Helvetica" pitchFamily="34" charset="-120"/>
+              </a:rPr>
+              <a:t>Buka Sheets-mu → Extensions → Apps Script.</a:t>
+            </a:r>
+            <a:endParaRPr lang="en-US" sz="1200" dirty="0"/>
+          </a:p>
+        </p:txBody>
+      </p:sp>
+      <p:sp>
+        <p:nvSpPr>
+          <p:cNvPr id="16" name="Shape 14"/>
+          <p:cNvSpPr/>
+          <p:nvPr/>
+        </p:nvSpPr>
+        <p:spPr>
+          <a:xfrm>
+            <a:off x="4332122" y="3830384"/>
+            <a:ext cx="3527450" cy="1261750"/>
+          </a:xfrm>
+          <a:prstGeom prst="roundRect">
+            <a:avLst>
+              <a:gd name="adj" fmla="val 7247"/>
+            </a:avLst>
+          </a:prstGeom>
+          <a:solidFill>
+            <a:srgbClr val="F3F0FF"/>
+          </a:solidFill>
+          <a:ln w="12700">
+            <a:solidFill>
+              <a:srgbClr val="DCD3FB"/>
+            </a:solidFill>
+            <a:prstDash val="solid"/>
+          </a:ln>
+        </p:spPr>
+      </p:sp>
+      <p:sp>
+        <p:nvSpPr>
+          <p:cNvPr id="17" name="Shape 15"/>
+          <p:cNvSpPr/>
+          <p:nvPr/>
+        </p:nvSpPr>
+        <p:spPr>
+          <a:xfrm>
+            <a:off x="4533290" y="4031552"/>
+            <a:ext cx="384048" cy="384048"/>
+          </a:xfrm>
+          <a:prstGeom prst="ellipse">
+            <a:avLst/>
+          </a:prstGeom>
+          <a:solidFill>
+            <a:srgbClr val="6849F6"/>
+          </a:solidFill>
+          <a:ln/>
+        </p:spPr>
+      </p:sp>
+      <p:sp>
+        <p:nvSpPr>
+          <p:cNvPr id="18" name="Text 16"/>
+          <p:cNvSpPr/>
+          <p:nvPr/>
+        </p:nvSpPr>
+        <p:spPr>
+          <a:xfrm>
+            <a:off x="4533290" y="4031552"/>
+            <a:ext cx="384048" cy="384048"/>
+          </a:xfrm>
+          <a:prstGeom prst="rect">
+            <a:avLst/>
+          </a:prstGeom>
+          <a:noFill/>
+          <a:ln/>
+        </p:spPr>
+        <p:txBody>
+          <a:bodyPr wrap="square" lIns="0" tIns="0" rIns="0" bIns="0" rtlCol="0" anchor="ctr"/>
+          <a:lstStyle/>
+          <a:p>
+            <a:pPr algn="ctr" indent="0" marL="0">
+              <a:buNone/>
+            </a:pPr>
+            <a:r>
+              <a:rPr lang="en-US" sz="1400" b="1" dirty="0">
+                <a:solidFill>
+                  <a:srgbClr val="FFFFFF"/>
+                </a:solidFill>
+                <a:latin typeface="Helvetica" pitchFamily="34" charset="0"/>
+                <a:ea typeface="Helvetica" pitchFamily="34" charset="-122"/>
+                <a:cs typeface="Helvetica" pitchFamily="34" charset="-120"/>
+              </a:rPr>
+              <a:t>2</a:t>
+            </a:r>
+            <a:endParaRPr lang="en-US" sz="1400" dirty="0"/>
+          </a:p>
+        </p:txBody>
+      </p:sp>
+      <p:sp>
+        <p:nvSpPr>
+          <p:cNvPr id="19" name="Text 17"/>
+          <p:cNvSpPr/>
+          <p:nvPr/>
+        </p:nvSpPr>
+        <p:spPr>
+          <a:xfrm>
+            <a:off x="5054498" y="4013264"/>
+            <a:ext cx="2603906" cy="310896"/>
+          </a:xfrm>
+          <a:prstGeom prst="rect">
+            <a:avLst/>
+          </a:prstGeom>
+          <a:noFill/>
+          <a:ln/>
+        </p:spPr>
+        <p:txBody>
+          <a:bodyPr wrap="square" lIns="0" tIns="0" rIns="0" bIns="0" rtlCol="0" anchor="ctr"/>
+          <a:lstStyle/>
+          <a:p>
+            <a:pPr indent="0" marL="0">
+              <a:buNone/>
+            </a:pPr>
+            <a:r>
+              <a:rPr lang="en-US" sz="1400" b="1" dirty="0">
+                <a:solidFill>
+                  <a:srgbClr val="0D1321"/>
+                </a:solidFill>
+                <a:latin typeface="Helvetica" pitchFamily="34" charset="0"/>
+                <a:ea typeface="Helvetica" pitchFamily="34" charset="-122"/>
+                <a:cs typeface="Helvetica" pitchFamily="34" charset="-120"/>
+              </a:rPr>
+              <a:t>Paste &amp; Save</a:t>
+            </a:r>
+            <a:endParaRPr lang="en-US" sz="1400" dirty="0"/>
+          </a:p>
+        </p:txBody>
+      </p:sp>
+      <p:sp>
+        <p:nvSpPr>
+          <p:cNvPr id="20" name="Text 18"/>
+          <p:cNvSpPr/>
+          <p:nvPr/>
+        </p:nvSpPr>
+        <p:spPr>
+          <a:xfrm>
+            <a:off x="4533290" y="4452176"/>
+            <a:ext cx="3125114" cy="438790"/>
+          </a:xfrm>
+          <a:prstGeom prst="rect">
+            <a:avLst/>
+          </a:prstGeom>
+          <a:noFill/>
+          <a:ln/>
+        </p:spPr>
+        <p:txBody>
+          <a:bodyPr wrap="square" lIns="0" tIns="0" rIns="0" bIns="0" rtlCol="0" anchor="t"/>
+          <a:lstStyle/>
+          <a:p>
+            <a:pPr indent="0" marL="0">
+              <a:lnSpc>
+                <a:spcPct val="122000"/>
+              </a:lnSpc>
+              <a:buNone/>
+            </a:pPr>
+            <a:r>
+              <a:rPr lang="en-US" sz="1200" dirty="0">
+                <a:solidFill>
+                  <a:srgbClr val="23283A"/>
+                </a:solidFill>
+                <a:latin typeface="Helvetica" pitchFamily="34" charset="0"/>
+                <a:ea typeface="Helvetica" pitchFamily="34" charset="-122"/>
+                <a:cs typeface="Helvetica" pitchFamily="34" charset="-120"/>
+              </a:rPr>
+              <a:t>Hapus kode lama, paste isi file ini, Save.</a:t>
+            </a:r>
+            <a:endParaRPr lang="en-US" sz="1200" dirty="0"/>
+          </a:p>
+        </p:txBody>
+      </p:sp>
+      <p:sp>
+        <p:nvSpPr>
+          <p:cNvPr id="21" name="Shape 19"/>
+          <p:cNvSpPr/>
+          <p:nvPr/>
+        </p:nvSpPr>
+        <p:spPr>
+          <a:xfrm>
+            <a:off x="8115605" y="3830384"/>
+            <a:ext cx="3527450" cy="1261750"/>
+          </a:xfrm>
+          <a:prstGeom prst="roundRect">
+            <a:avLst>
+              <a:gd name="adj" fmla="val 7247"/>
+            </a:avLst>
+          </a:prstGeom>
+          <a:solidFill>
+            <a:srgbClr val="F3F0FF"/>
+          </a:solidFill>
+          <a:ln w="12700">
+            <a:solidFill>
+              <a:srgbClr val="DCD3FB"/>
+            </a:solidFill>
+            <a:prstDash val="solid"/>
+          </a:ln>
+        </p:spPr>
+      </p:sp>
+      <p:sp>
+        <p:nvSpPr>
+          <p:cNvPr id="22" name="Shape 20"/>
+          <p:cNvSpPr/>
+          <p:nvPr/>
+        </p:nvSpPr>
+        <p:spPr>
+          <a:xfrm>
+            <a:off x="8316773" y="4031552"/>
+            <a:ext cx="384048" cy="384048"/>
+          </a:xfrm>
+          <a:prstGeom prst="ellipse">
+            <a:avLst/>
+          </a:prstGeom>
+          <a:solidFill>
+            <a:srgbClr val="6849F6"/>
+          </a:solidFill>
+          <a:ln/>
+        </p:spPr>
+      </p:sp>
+      <p:sp>
+        <p:nvSpPr>
+          <p:cNvPr id="23" name="Text 21"/>
+          <p:cNvSpPr/>
+          <p:nvPr/>
+        </p:nvSpPr>
+        <p:spPr>
+          <a:xfrm>
+            <a:off x="8316773" y="4031552"/>
+            <a:ext cx="384048" cy="384048"/>
+          </a:xfrm>
+          <a:prstGeom prst="rect">
+            <a:avLst/>
+          </a:prstGeom>
+          <a:noFill/>
+          <a:ln/>
+        </p:spPr>
+        <p:txBody>
+          <a:bodyPr wrap="square" lIns="0" tIns="0" rIns="0" bIns="0" rtlCol="0" anchor="ctr"/>
+          <a:lstStyle/>
+          <a:p>
+            <a:pPr algn="ctr" indent="0" marL="0">
+              <a:buNone/>
+            </a:pPr>
+            <a:r>
+              <a:rPr lang="en-US" sz="1400" b="1" dirty="0">
+                <a:solidFill>
+                  <a:srgbClr val="FFFFFF"/>
+                </a:solidFill>
+                <a:latin typeface="Helvetica" pitchFamily="34" charset="0"/>
+                <a:ea typeface="Helvetica" pitchFamily="34" charset="-122"/>
+                <a:cs typeface="Helvetica" pitchFamily="34" charset="-120"/>
+              </a:rPr>
+              <a:t>3</a:t>
+            </a:r>
+            <a:endParaRPr lang="en-US" sz="1400" dirty="0"/>
+          </a:p>
+        </p:txBody>
+      </p:sp>
+      <p:sp>
+        <p:nvSpPr>
+          <p:cNvPr id="24" name="Text 22"/>
+          <p:cNvSpPr/>
+          <p:nvPr/>
+        </p:nvSpPr>
+        <p:spPr>
+          <a:xfrm>
+            <a:off x="8837981" y="4013264"/>
+            <a:ext cx="2603906" cy="310896"/>
+          </a:xfrm>
+          <a:prstGeom prst="rect">
+            <a:avLst/>
+          </a:prstGeom>
+          <a:noFill/>
+          <a:ln/>
+        </p:spPr>
+        <p:txBody>
+          <a:bodyPr wrap="square" lIns="0" tIns="0" rIns="0" bIns="0" rtlCol="0" anchor="ctr"/>
+          <a:lstStyle/>
+          <a:p>
+            <a:pPr indent="0" marL="0">
+              <a:buNone/>
+            </a:pPr>
+            <a:r>
+              <a:rPr lang="en-US" sz="1400" b="1" dirty="0">
+                <a:solidFill>
+                  <a:srgbClr val="0D1321"/>
+                </a:solidFill>
+                <a:latin typeface="Helvetica" pitchFamily="34" charset="0"/>
+                <a:ea typeface="Helvetica" pitchFamily="34" charset="-122"/>
+                <a:cs typeface="Helvetica" pitchFamily="34" charset="-120"/>
+              </a:rPr>
+              <a:t>Allow Akses</a:t>
+            </a:r>
+            <a:endParaRPr lang="en-US" sz="1400" dirty="0"/>
+          </a:p>
+        </p:txBody>
+      </p:sp>
+      <p:sp>
+        <p:nvSpPr>
+          <p:cNvPr id="25" name="Text 23"/>
+          <p:cNvSpPr/>
+          <p:nvPr/>
+        </p:nvSpPr>
+        <p:spPr>
+          <a:xfrm>
+            <a:off x="8316773" y="4452176"/>
+            <a:ext cx="3125114" cy="438790"/>
+          </a:xfrm>
+          <a:prstGeom prst="rect">
+            <a:avLst/>
+          </a:prstGeom>
+          <a:noFill/>
+          <a:ln/>
+        </p:spPr>
+        <p:txBody>
+          <a:bodyPr wrap="square" lIns="0" tIns="0" rIns="0" bIns="0" rtlCol="0" anchor="t"/>
+          <a:lstStyle/>
+          <a:p>
+            <a:pPr indent="0" marL="0">
+              <a:lnSpc>
+                <a:spcPct val="122000"/>
+              </a:lnSpc>
+              <a:buNone/>
+            </a:pPr>
+            <a:r>
+              <a:rPr lang="en-US" sz="1200" dirty="0">
+                <a:solidFill>
+                  <a:srgbClr val="23283A"/>
+                </a:solidFill>
+                <a:latin typeface="Helvetica" pitchFamily="34" charset="0"/>
+                <a:ea typeface="Helvetica" pitchFamily="34" charset="-122"/>
+                <a:cs typeface="Helvetica" pitchFamily="34" charset="-120"/>
+              </a:rPr>
+              <a:t>Refresh Sheets, klik Allow saat diminta izin.</a:t>
+            </a:r>
+            <a:endParaRPr lang="en-US" sz="1200" dirty="0"/>
           </a:p>
         </p:txBody>
       </p:sp>

</xml_diff>

<commit_message>
K2 M4: fix data mismatch (CSV was employee salary data, now correct product sales matching lesson text); enhance PDF export script with Rupiah formatting, report header, and chart builder
</commit_message>
<xml_diff>
--- a/K2-Produktivitas/M04-Google-Sheets/K2-M04-Google-Sheets.pptx
+++ b/K2-Produktivitas/M04-Google-Sheets/K2-M04-Google-Sheets.pptx
@@ -4697,7 +4697,7 @@
                 <a:ea typeface="Helvetica" pitchFamily="34" charset="-122"/>
                 <a:cs typeface="Helvetica" pitchFamily="34" charset="-120"/>
               </a:rPr>
-              <a:t>Google Apps Script yang menambahkan menu “Export PDF” ke Sheets-mu: export sheet aktif atau rentang terpilih jadi PDF rapi, tersimpan otomatis ke Drive. Script ini dibuat dengan cara memprompt Claude langsung — tidak ada API key atau paket Pro yang dibutuhkan, cuma fitur bawaan Google.</a:t>
+              <a:t>Google Apps Script yang menambahkan menu “Export PDF” ke Sheets-mu: rapikan angka jadi format Rupiah, tambah judul laporan, buat grafik kolom ringkas, lalu export sheet aktif atau rentang terpilih jadi PDF rapi ke Drive. Dibuat dengan memprompt Claude langsung — tidak ada API key atau paket Pro yang dibutuhkan.</a:t>
             </a:r>
             <a:endParaRPr lang="en-US" sz="1250" dirty="0"/>
           </a:p>
@@ -4822,7 +4822,7 @@
                 <a:ea typeface="Helvetica" pitchFamily="34" charset="-122"/>
                 <a:cs typeface="Helvetica" pitchFamily="34" charset="-120"/>
               </a:rPr>
-              <a:t>Extensions</a:t>
+              <a:t>Rapikan &amp; Beri Judul</a:t>
             </a:r>
             <a:endParaRPr lang="en-US" sz="1400" dirty="0"/>
           </a:p>
@@ -4864,7 +4864,7 @@
                 <a:ea typeface="Helvetica" pitchFamily="34" charset="-122"/>
                 <a:cs typeface="Helvetica" pitchFamily="34" charset="-120"/>
               </a:rPr>
-              <a:t>Buka Sheets-mu → Extensions → Apps Script.</a:t>
+              <a:t>Pilih kolom angka → format Rupiah. Pilih data → tambah judul laporan.</a:t>
             </a:r>
             <a:endParaRPr lang="en-US" sz="1200" dirty="0"/>
           </a:p>
@@ -4989,7 +4989,7 @@
                 <a:ea typeface="Helvetica" pitchFamily="34" charset="-122"/>
                 <a:cs typeface="Helvetica" pitchFamily="34" charset="-120"/>
               </a:rPr>
-              <a:t>Paste &amp; Save</a:t>
+              <a:t>Buat Grafik</a:t>
             </a:r>
             <a:endParaRPr lang="en-US" sz="1400" dirty="0"/>
           </a:p>
@@ -5031,7 +5031,7 @@
                 <a:ea typeface="Helvetica" pitchFamily="34" charset="-122"/>
                 <a:cs typeface="Helvetica" pitchFamily="34" charset="-120"/>
               </a:rPr>
-              <a:t>Hapus kode lama, paste isi file ini, Save.</a:t>
+              <a:t>Pilih Nama Produk + 1 kolom angka → Buat Grafik Ringkas.</a:t>
             </a:r>
             <a:endParaRPr lang="en-US" sz="1200" dirty="0"/>
           </a:p>
@@ -5156,7 +5156,7 @@
                 <a:ea typeface="Helvetica" pitchFamily="34" charset="-122"/>
                 <a:cs typeface="Helvetica" pitchFamily="34" charset="-120"/>
               </a:rPr>
-              <a:t>Allow Akses</a:t>
+              <a:t>Export PDF</a:t>
             </a:r>
             <a:endParaRPr lang="en-US" sz="1400" dirty="0"/>
           </a:p>
@@ -5198,7 +5198,7 @@
                 <a:ea typeface="Helvetica" pitchFamily="34" charset="-122"/>
                 <a:cs typeface="Helvetica" pitchFamily="34" charset="-120"/>
               </a:rPr>
-              <a:t>Refresh Sheets, klik Allow saat diminta izin.</a:t>
+              <a:t>Jalankan Export — judul, angka rapi, dan grafik ikut ter-export.</a:t>
             </a:r>
             <a:endParaRPr lang="en-US" sz="1200" dirty="0"/>
           </a:p>

</xml_diff>

<commit_message>
K2 M4: remove inconsistent Rina stats from intro (replace with generic Sheets+Claude framing); fix PPT compare-cards color/icon order to match HTML semantics (Aman=highlighted, Hindari=plain)
</commit_message>
<xml_diff>
--- a/K2-Produktivitas/M04-Google-Sheets/K2-M04-Google-Sheets.pptx
+++ b/K2-Produktivitas/M04-Google-Sheets/K2-M04-Google-Sheets.pptx
@@ -2753,7 +2753,7 @@
                 <a:ea typeface="Helvetica" pitchFamily="34" charset="-122"/>
                 <a:cs typeface="Helvetica" pitchFamily="34" charset="-120"/>
               </a:rPr>
-              <a:t>AMAN DIBAGIKAN</a:t>
+              <a:t>⚠ HINDARI DIBAGIKAN</a:t>
             </a:r>
             <a:endParaRPr lang="en-US" sz="1200" dirty="0"/>
           </a:p>
@@ -2795,7 +2795,7 @@
                 <a:ea typeface="Helvetica" pitchFamily="34" charset="-122"/>
                 <a:cs typeface="Helvetica" pitchFamily="34" charset="-120"/>
               </a:rPr>
-              <a:t>•  Nama produk, kategori, harga</a:t>
+              <a:t>•  Nama lengkap + nomor telepon pelanggan</a:t>
             </a:r>
             <a:endParaRPr lang="en-US" sz="1200" dirty="0"/>
           </a:p>
@@ -2815,7 +2815,7 @@
                 <a:ea typeface="Helvetica" pitchFamily="34" charset="-122"/>
                 <a:cs typeface="Helvetica" pitchFamily="34" charset="-120"/>
               </a:rPr>
-              <a:t>•  Jumlah penjualan per periode</a:t>
+              <a:t>•  Nomor kartu kredit / rekening</a:t>
             </a:r>
             <a:endParaRPr lang="en-US" sz="1200" dirty="0"/>
           </a:p>
@@ -2835,7 +2835,7 @@
                 <a:ea typeface="Helvetica" pitchFamily="34" charset="-122"/>
                 <a:cs typeface="Helvetica" pitchFamily="34" charset="-120"/>
               </a:rPr>
-              <a:t>•  Data performa (tanpa nama pelanggan)</a:t>
+              <a:t>•  Password atau API key</a:t>
             </a:r>
             <a:endParaRPr lang="en-US" sz="1200" dirty="0"/>
           </a:p>
@@ -2855,7 +2855,7 @@
                 <a:ea typeface="Helvetica" pitchFamily="34" charset="-122"/>
                 <a:cs typeface="Helvetica" pitchFamily="34" charset="-120"/>
               </a:rPr>
-              <a:t>•  Struktur kolom dan formula</a:t>
+              <a:t>•  Data karyawan dengan info personal</a:t>
             </a:r>
             <a:endParaRPr lang="en-US" sz="1200" dirty="0"/>
           </a:p>
@@ -2921,7 +2921,7 @@
                 <a:ea typeface="Helvetica" pitchFamily="34" charset="-122"/>
                 <a:cs typeface="Helvetica" pitchFamily="34" charset="-120"/>
               </a:rPr>
-              <a:t>HINDARI DIBAGIKAN</a:t>
+              <a:t>✓ AMAN DIBAGIKAN</a:t>
             </a:r>
             <a:endParaRPr lang="en-US" sz="1200" dirty="0"/>
           </a:p>
@@ -2963,7 +2963,7 @@
                 <a:ea typeface="Helvetica" pitchFamily="34" charset="-122"/>
                 <a:cs typeface="Helvetica" pitchFamily="34" charset="-120"/>
               </a:rPr>
-              <a:t>•  Nama lengkap + nomor telepon pelanggan</a:t>
+              <a:t>•  Nama produk, kategori, harga</a:t>
             </a:r>
             <a:endParaRPr lang="en-US" sz="1200" dirty="0"/>
           </a:p>
@@ -2983,7 +2983,7 @@
                 <a:ea typeface="Helvetica" pitchFamily="34" charset="-122"/>
                 <a:cs typeface="Helvetica" pitchFamily="34" charset="-120"/>
               </a:rPr>
-              <a:t>•  Nomor kartu kredit / rekening</a:t>
+              <a:t>•  Jumlah penjualan per periode</a:t>
             </a:r>
             <a:endParaRPr lang="en-US" sz="1200" dirty="0"/>
           </a:p>
@@ -3003,7 +3003,7 @@
                 <a:ea typeface="Helvetica" pitchFamily="34" charset="-122"/>
                 <a:cs typeface="Helvetica" pitchFamily="34" charset="-120"/>
               </a:rPr>
-              <a:t>•  Password atau API key</a:t>
+              <a:t>•  Data performa (tanpa nama pelanggan)</a:t>
             </a:r>
             <a:endParaRPr lang="en-US" sz="1200" dirty="0"/>
           </a:p>
@@ -3023,7 +3023,7 @@
                 <a:ea typeface="Helvetica" pitchFamily="34" charset="-122"/>
                 <a:cs typeface="Helvetica" pitchFamily="34" charset="-120"/>
               </a:rPr>
-              <a:t>•  Data karyawan dengan info personal</a:t>
+              <a:t>•  Struktur kolom dan formula</a:t>
             </a:r>
             <a:endParaRPr lang="en-US" sz="1200" dirty="0"/>
           </a:p>

</xml_diff>

<commit_message>
K2 M4: sync HTML/PDF wording to match PPT (Sheets cards, section titles, prompt steps, bonus openings); fix PPT filename bug (k2-data-penjualan.csv -> real k2-data-latihan-sheets.csv); rename helper script .js->.txt with beginner-friendly Notepad/TextEdit install steps
</commit_message>
<xml_diff>
--- a/K2-Produktivitas/M04-Google-Sheets/K2-M04-Google-Sheets.pptx
+++ b/K2-Produktivitas/M04-Google-Sheets/K2-M04-Google-Sheets.pptx
@@ -4158,7 +4158,7 @@
                 <a:ea typeface="Helvetica" pitchFamily="34" charset="-122"/>
                 <a:cs typeface="Helvetica" pitchFamily="34" charset="-120"/>
               </a:rPr>
-              <a:t>Download file latihan k2-data-penjualan.csv dari halaman materi. Import ke Google Sheets. Minta Claude buat 3 formula dasar (total, rata-rata, % target). Paste 5 baris data ke Claude dan minta analisis pola. Tanya: "Dari data ini, produk mana yang harus saya prioritaskan bulan depan?"</a:t>
+              <a:t>Download file latihan k2-data-latihan-sheets.csv dari halaman materi. Import ke Google Sheets. Minta Claude buat 3 formula dasar (total, rata-rata, % target). Paste 5 baris data ke Claude dan minta analisis pola. Tanya: "Dari data ini, produk mana yang harus saya prioritaskan bulan depan?"</a:t>
             </a:r>
             <a:endParaRPr lang="en-US" sz="1250" dirty="0"/>
           </a:p>
@@ -4655,7 +4655,7 @@
                 <a:ea typeface="Helvetica" pitchFamily="34" charset="-122"/>
                 <a:cs typeface="Helvetica" pitchFamily="34" charset="-120"/>
               </a:rPr>
-              <a:t>◆  DOWNLOAD K2-PDF-EXPORT-HELPER.JS — 100% GRATIS</a:t>
+              <a:t>◆  DOWNLOAD K2-PDF-EXPORT-HELPER.TXT — 100% GRATIS</a:t>
             </a:r>
             <a:endParaRPr lang="en-US" sz="1250" dirty="0"/>
           </a:p>

</xml_diff>

<commit_message>
K2 M4: rename module to Spreadsheet & Claude, add Excel intro, restructure CSV to transactional data (~180 rows), generic Alur Prompt with new Excel-file-output step, remove 100% Gratis labels, add workflow automation title, move Claude in Chrome tip to bottom, label Apps Script as Sheets-specific with VBA pointer
</commit_message>
<xml_diff>
--- a/K2-Produktivitas/M04-Google-Sheets/K2-M04-Google-Sheets.pptx
+++ b/K2-Produktivitas/M04-Google-Sheets/K2-M04-Google-Sheets.pptx
@@ -1618,7 +1618,7 @@
                 <a:ea typeface="Helvetica" pitchFamily="34" charset="-122"/>
                 <a:cs typeface="Helvetica" pitchFamily="34" charset="-120"/>
               </a:rPr>
-              <a:t>Google Sheets</a:t>
+              <a:t>Spreadsheet &amp; Claude</a:t>
             </a:r>
             <a:endParaRPr lang="en-US" sz="4400" dirty="0"/>
           </a:p>
@@ -1824,7 +1824,7 @@
                 <a:ea typeface="Helvetica" pitchFamily="34" charset="-122"/>
                 <a:cs typeface="Helvetica" pitchFamily="34" charset="-120"/>
               </a:rPr>
-              <a:t>Modul 04 — Google Sheets + Claude</a:t>
+              <a:t>Modul 04 — Spreadsheet &amp; Claude</a:t>
             </a:r>
             <a:endParaRPr lang="en-US" sz="1250" dirty="0"/>
           </a:p>
@@ -1863,7 +1863,7 @@
                 <a:ea typeface="Helvetica" pitchFamily="34" charset="-122"/>
                 <a:cs typeface="Helvetica" pitchFamily="34" charset="-120"/>
               </a:rPr>
-              <a:t>Yang Bisa Claude Bantu di Sheets</a:t>
+              <a:t>Yang Bisa Claude Bantu di Spreadsheet</a:t>
             </a:r>
             <a:endParaRPr lang="en-US" sz="2200" dirty="0"/>
           </a:p>
@@ -2418,7 +2418,7 @@
         <p:spPr>
           <a:xfrm>
             <a:off x="548640" y="4050548"/>
-            <a:ext cx="11094415" cy="249367"/>
+            <a:ext cx="11094415" cy="498734"/>
           </a:xfrm>
           <a:prstGeom prst="rect">
             <a:avLst/>
@@ -2445,7 +2445,7 @@
                 <a:ea typeface="Helvetica" pitchFamily="34" charset="-122"/>
                 <a:cs typeface="Helvetica" pitchFamily="34" charset="-120"/>
               </a:rPr>
-              <a:t>Tips: Selalu sebutkan struktur kolom data dulu sebelum bertanya — Claude bekerja lebih akurat kalau tahu konteks kolomnya.</a:t>
+              <a:t>Tips: Selalu sebutkan struktur kolom data dulu sebelum bertanya — Claude bekerja lebih akurat kalau tahu konteks kolomnya. Berlaku sama di Google Sheets maupun Excel.</a:t>
             </a:r>
             <a:endParaRPr lang="en-US" sz="1300" dirty="0"/>
           </a:p>
@@ -2609,7 +2609,7 @@
                 <a:ea typeface="Helvetica" pitchFamily="34" charset="-122"/>
                 <a:cs typeface="Helvetica" pitchFamily="34" charset="-120"/>
               </a:rPr>
-              <a:t>Modul 04 — Google Sheets + Claude</a:t>
+              <a:t>Modul 04 — Spreadsheet &amp; Claude</a:t>
             </a:r>
             <a:endParaRPr lang="en-US" sz="1250" dirty="0"/>
           </a:p>
@@ -3187,7 +3187,7 @@
                 <a:ea typeface="Helvetica" pitchFamily="34" charset="-122"/>
                 <a:cs typeface="Helvetica" pitchFamily="34" charset="-120"/>
               </a:rPr>
-              <a:t>Modul 04 — Google Sheets + Claude</a:t>
+              <a:t>Modul 04 — Spreadsheet &amp; Claude</a:t>
             </a:r>
             <a:endParaRPr lang="en-US" sz="1250" dirty="0"/>
           </a:p>
@@ -3265,7 +3265,7 @@
                 <a:ea typeface="Helvetica" pitchFamily="34" charset="-122"/>
                 <a:cs typeface="Helvetica" pitchFamily="34" charset="-120"/>
               </a:rPr>
-              <a:t>CONTOH NYATA — RINA, KASUAL STUDIO</a:t>
+              <a:t>3 LANGKAH DARI DATA KE FILE SIAP DIBAGIKAN</a:t>
             </a:r>
             <a:endParaRPr lang="en-US" sz="1250" dirty="0"/>
           </a:p>
@@ -3432,7 +3432,7 @@
                 <a:ea typeface="Helvetica" pitchFamily="34" charset="-122"/>
                 <a:cs typeface="Helvetica" pitchFamily="34" charset="-120"/>
               </a:rPr>
-              <a:t>"Sheet saya: A=Nama Produk, B=Jan, C=Feb, D=Mar, E=Target. Buatkan formula total Jan–Mar di F2, dan % pencapaian target di G2."</a:t>
+              <a:t>"Data saya kolom: Tanggal, Order ID, Produk, Region, Sales, Qty, Harga Satuan, Total. Buatkan formula SUMIF total revenue per Produk dan per Region."</a:t>
             </a:r>
             <a:endParaRPr lang="en-US" sz="1200" dirty="0"/>
           </a:p>
@@ -3557,7 +3557,7 @@
                 <a:ea typeface="Helvetica" pitchFamily="34" charset="-122"/>
                 <a:cs typeface="Helvetica" pitchFamily="34" charset="-120"/>
               </a:rPr>
-              <a:t>Analisis</a:t>
+              <a:t>Analisis &amp; Rekomendasi</a:t>
             </a:r>
             <a:endParaRPr lang="en-US" sz="1400" dirty="0"/>
           </a:p>
@@ -3599,7 +3599,7 @@
                 <a:ea typeface="Helvetica" pitchFamily="34" charset="-122"/>
                 <a:cs typeface="Helvetica" pitchFamily="34" charset="-120"/>
               </a:rPr>
-              <a:t>"Ini data penjualan 3 bulan terakhir: [paste]. Produk mana performa paling konsisten? Mana tren naik vs turun?"</a:t>
+              <a:t>"Ini data transaksi beberapa bulan terakhir: [paste]. Produk/region mana paling laris? Ada tren naik-turun? Kasih rekomendasi."</a:t>
             </a:r>
             <a:endParaRPr lang="en-US" sz="1200" dirty="0"/>
           </a:p>
@@ -3724,7 +3724,7 @@
                 <a:ea typeface="Helvetica" pitchFamily="34" charset="-122"/>
                 <a:cs typeface="Helvetica" pitchFamily="34" charset="-120"/>
               </a:rPr>
-              <a:t>Keputusan</a:t>
+              <a:t>File Excel Ringkasan</a:t>
             </a:r>
             <a:endParaRPr lang="en-US" sz="1400" dirty="0"/>
           </a:p>
@@ -3766,7 +3766,7 @@
                 <a:ea typeface="Helvetica" pitchFamily="34" charset="-122"/>
                 <a:cs typeface="Helvetica" pitchFamily="34" charset="-120"/>
               </a:rPr>
-              <a:t>"Budget restock saya Rp 5 juta. Sarankan alokasi paling optimal berdasarkan data performa tadi."</a:t>
+              <a:t>"Dari analisis tadi, buatkan file Excel ringkasan: per produk, per region, plus insight &amp; rekomendasi — siap dibagikan ke tim."</a:t>
             </a:r>
             <a:endParaRPr lang="en-US" sz="1200" dirty="0"/>
           </a:p>
@@ -3781,7 +3781,7 @@
         <p:spPr>
           <a:xfrm>
             <a:off x="548640" y="4050548"/>
-            <a:ext cx="11094415" cy="249367"/>
+            <a:ext cx="11094415" cy="498734"/>
           </a:xfrm>
           <a:prstGeom prst="rect">
             <a:avLst/>
@@ -3808,7 +3808,7 @@
                 <a:ea typeface="Helvetica" pitchFamily="34" charset="-122"/>
                 <a:cs typeface="Helvetica" pitchFamily="34" charset="-120"/>
               </a:rPr>
-              <a:t>Tips: "produk mana yang harus saya prioritaskan bulan depan?" — pertanyaan penutup yang mengubah data jadi keputusan.</a:t>
+              <a:t>Tips: Step 2 dan 3 adalah dua deliverable berbeda dari satu alur — rekomendasi di chat untuk keputusan cepat, file Excel untuk yang perlu dibagikan ke orang lain.</a:t>
             </a:r>
             <a:endParaRPr lang="en-US" sz="1300" dirty="0"/>
           </a:p>
@@ -3972,7 +3972,7 @@
                 <a:ea typeface="Helvetica" pitchFamily="34" charset="-122"/>
                 <a:cs typeface="Helvetica" pitchFamily="34" charset="-120"/>
               </a:rPr>
-              <a:t>Modul 04 — Google Sheets + Claude</a:t>
+              <a:t>Modul 04 — Spreadsheet &amp; Claude</a:t>
             </a:r>
             <a:endParaRPr lang="en-US" sz="1250" dirty="0"/>
           </a:p>
@@ -4158,7 +4158,7 @@
                 <a:ea typeface="Helvetica" pitchFamily="34" charset="-122"/>
                 <a:cs typeface="Helvetica" pitchFamily="34" charset="-120"/>
               </a:rPr>
-              <a:t>Download file latihan k2-data-latihan-sheets.csv dari halaman materi. Import ke Google Sheets. Minta Claude buat 3 formula dasar (total, rata-rata, % target). Paste 5 baris data ke Claude dan minta analisis pola. Tanya: "Dari data ini, produk mana yang harus saya prioritaskan bulan depan?"</a:t>
+              <a:t>Download k2-data-latihan-sheets.csv — data transaksi Kasual Studio (April–Juli 2026, ~180 baris: Tanggal, Order ID, Produk, Region, Sales, Qty, Harga Satuan, Total). Minta Claude buat formula SUMIF per Produk &amp; Region. Paste contoh data, minta analisis + rekomendasi. Lalu minta file Excel ringkasannya.</a:t>
             </a:r>
             <a:endParaRPr lang="en-US" sz="1250" dirty="0"/>
           </a:p>
@@ -4266,7 +4266,7 @@
                 <a:ea typeface="Helvetica" pitchFamily="34" charset="-122"/>
                 <a:cs typeface="Helvetica" pitchFamily="34" charset="-120"/>
               </a:rPr>
-              <a:t>Sheet dengan 3 formula berjalan + 1 paragraf analisis dari Claude tentang pola performa berdasarkan data kamu.</a:t>
+              <a:t>Formula SUMIF berjalan di sheet, insight &amp; rekomendasi dari Claude di chat, dan 1 file Excel ringkasan siap dibagikan ke tim.</a:t>
             </a:r>
             <a:endParaRPr lang="en-US" sz="1250" dirty="0"/>
           </a:p>
@@ -4320,7 +4320,7 @@
         <p:spPr>
           <a:xfrm>
             <a:off x="548640" y="5390642"/>
-            <a:ext cx="11094415" cy="719328"/>
+            <a:ext cx="11094415" cy="479552"/>
           </a:xfrm>
           <a:prstGeom prst="rect">
             <a:avLst/>
@@ -4347,7 +4347,7 @@
                 <a:ea typeface="Helvetica" pitchFamily="34" charset="-122"/>
                 <a:cs typeface="Helvetica" pitchFamily="34" charset="-120"/>
               </a:rPr>
-              <a:t>Claude in Chrome bisa baca &amp; isi formula langsung di Google Sheets tanpa copy-paste — install extension dari Chrome Web Store. Butuh paket Pro atau lebih tinggi (tidak ada di Free). Untuk otomatisasi berulang (laporan mingguan, notifikasi stok habis), Claude bisa bantu tulis Google Apps Script.</a:t>
+              <a:t>Untuk otomatisasi berulang di Google Sheets (laporan mingguan, notifikasi stok habis), Claude bisa bantu tulis Google Apps Script — lihat detailnya di slide berikut.</a:t>
             </a:r>
             <a:endParaRPr lang="en-US" sz="1250" dirty="0"/>
           </a:p>
@@ -4511,7 +4511,7 @@
                 <a:ea typeface="Helvetica" pitchFamily="34" charset="-122"/>
                 <a:cs typeface="Helvetica" pitchFamily="34" charset="-120"/>
               </a:rPr>
-              <a:t>Modul 04 — Google Sheets + Claude</a:t>
+              <a:t>Modul 04 — Spreadsheet &amp; Claude</a:t>
             </a:r>
             <a:endParaRPr lang="en-US" sz="1250" dirty="0"/>
           </a:p>
@@ -4550,7 +4550,7 @@
                 <a:ea typeface="Helvetica" pitchFamily="34" charset="-122"/>
                 <a:cs typeface="Helvetica" pitchFamily="34" charset="-120"/>
               </a:rPr>
-              <a:t>Bonus: Menu “Export PDF” di Google Sheets</a:t>
+              <a:t>Bonus — Automasi Workflow: Menu "Export PDF" di Sheets</a:t>
             </a:r>
             <a:endParaRPr lang="en-US" sz="2200" dirty="0"/>
           </a:p>
@@ -4655,7 +4655,7 @@
                 <a:ea typeface="Helvetica" pitchFamily="34" charset="-122"/>
                 <a:cs typeface="Helvetica" pitchFamily="34" charset="-120"/>
               </a:rPr>
-              <a:t>◆  DOWNLOAD K2-PDF-EXPORT-HELPER.TXT — 100% GRATIS</a:t>
+              <a:t>◆  DOWNLOAD K2-PDF-EXPORT-HELPER.TXT</a:t>
             </a:r>
             <a:endParaRPr lang="en-US" sz="1250" dirty="0"/>
           </a:p>
@@ -4697,7 +4697,7 @@
                 <a:ea typeface="Helvetica" pitchFamily="34" charset="-122"/>
                 <a:cs typeface="Helvetica" pitchFamily="34" charset="-120"/>
               </a:rPr>
-              <a:t>Google Apps Script yang menambahkan menu “Export PDF” ke Sheets-mu: rapikan angka jadi format Rupiah, tambah judul laporan, buat grafik kolom ringkas, lalu export sheet aktif atau rentang terpilih jadi PDF rapi ke Drive. Dibuat dengan memprompt Claude langsung — tidak ada API key atau paket Pro yang dibutuhkan.</a:t>
+              <a:t>Google Apps Script yang menambahkan menu “Export PDF” ke Sheets-mu: rapikan angka jadi format Rupiah, tambah judul laporan, buat grafik kolom ringkas, lalu export sheet aktif atau rentang terpilih jadi PDF rapi ke Drive. Dibuat dengan memprompt Claude langsung — tidak ada API key atau paket Pro yang dibutuhkan. Khusus Google Sheets — di Excel, minta Claude tulis versi VBA macro dengan prompt serupa.</a:t>
             </a:r>
             <a:endParaRPr lang="en-US" sz="1250" dirty="0"/>
           </a:p>
@@ -4864,7 +4864,7 @@
                 <a:ea typeface="Helvetica" pitchFamily="34" charset="-122"/>
                 <a:cs typeface="Helvetica" pitchFamily="34" charset="-120"/>
               </a:rPr>
-              <a:t>Pilih kolom angka → format Rupiah. Pilih data → tambah judul laporan.</a:t>
+              <a:t>Pilih kolom hasil SUMIF → format Rupiah. Pilih data → tambah judul laporan.</a:t>
             </a:r>
             <a:endParaRPr lang="en-US" sz="1200" dirty="0"/>
           </a:p>
@@ -5031,7 +5031,7 @@
                 <a:ea typeface="Helvetica" pitchFamily="34" charset="-122"/>
                 <a:cs typeface="Helvetica" pitchFamily="34" charset="-120"/>
               </a:rPr>
-              <a:t>Pilih Nama Produk + 1 kolom angka → Buat Grafik Ringkas.</a:t>
+              <a:t>Pilih Nama Produk + Total Revenue → Buat Grafik Ringkas.</a:t>
             </a:r>
             <a:endParaRPr lang="en-US" sz="1200" dirty="0"/>
           </a:p>
@@ -5362,7 +5362,7 @@
                 <a:ea typeface="Helvetica" pitchFamily="34" charset="-122"/>
                 <a:cs typeface="Helvetica" pitchFamily="34" charset="-120"/>
               </a:rPr>
-              <a:t>Modul 04 — Google Sheets + Claude</a:t>
+              <a:t>Modul 04 — Spreadsheet &amp; Claude</a:t>
             </a:r>
             <a:endParaRPr lang="en-US" sz="1250" dirty="0"/>
           </a:p>
@@ -5548,9 +5548,117 @@
                 <a:ea typeface="Helvetica" pitchFamily="34" charset="-122"/>
                 <a:cs typeface="Helvetica" pitchFamily="34" charset="-120"/>
               </a:rPr>
-              <a:t>[Upload atau paste k2-data-latihan-sheets.csv] Dari data ini, buatkan saya dashboard HTML sederhana: tabel semua produk dengan kolom terjual, revenue, dan stok. Beri warna merah kalau stok di bawah 10, kuning kalau stagnan, hijau kalau performa bagus. Simpan sebagai 1 file HTML yang bisa saya buka tiap minggu.</a:t>
+              <a:t>[Upload atau paste k2-data-latihan-sheets.csv] Dari data transaksi ini, buatkan saya dashboard HTML sederhana: tabel semua produk dengan kolom total qty terjual dan total revenue (SUMIF per Produk). Beri warna hijau kalau revenue di atas rata-rata semua produk, kuning kalau mendekati rata-rata, merah kalau jauh di bawah rata-rata. Simpan sebagai 1 file HTML yang bisa saya buka tiap minggu.</a:t>
             </a:r>
             <a:endParaRPr lang="en-US" sz="1100" dirty="0"/>
+          </a:p>
+        </p:txBody>
+      </p:sp>
+      <p:sp>
+        <p:nvSpPr>
+          <p:cNvPr id="11" name="Shape 9"/>
+          <p:cNvSpPr/>
+          <p:nvPr/>
+        </p:nvSpPr>
+        <p:spPr>
+          <a:xfrm>
+            <a:off x="548640" y="3779291"/>
+            <a:ext cx="11094415" cy="1236853"/>
+          </a:xfrm>
+          <a:prstGeom prst="roundRect">
+            <a:avLst>
+              <a:gd name="adj" fmla="val 7393"/>
+            </a:avLst>
+          </a:prstGeom>
+          <a:solidFill>
+            <a:srgbClr val="F3F0FF"/>
+          </a:solidFill>
+          <a:ln w="12700">
+            <a:solidFill>
+              <a:srgbClr val="DCD3FB"/>
+            </a:solidFill>
+            <a:prstDash val="solid"/>
+          </a:ln>
+        </p:spPr>
+      </p:sp>
+      <p:sp>
+        <p:nvSpPr>
+          <p:cNvPr id="12" name="Text 10"/>
+          <p:cNvSpPr/>
+          <p:nvPr/>
+        </p:nvSpPr>
+        <p:spPr>
+          <a:xfrm>
+            <a:off x="749808" y="3980459"/>
+            <a:ext cx="10692079" cy="274320"/>
+          </a:xfrm>
+          <a:prstGeom prst="rect">
+            <a:avLst/>
+          </a:prstGeom>
+          <a:noFill/>
+          <a:ln/>
+        </p:spPr>
+        <p:txBody>
+          <a:bodyPr wrap="square" lIns="0" tIns="0" rIns="0" bIns="0" rtlCol="0" anchor="ctr"/>
+          <a:lstStyle/>
+          <a:p>
+            <a:pPr indent="0" marL="0">
+              <a:buNone/>
+            </a:pPr>
+            <a:r>
+              <a:rPr lang="en-US" sz="1250" b="1" spc="30" kern="0" dirty="0">
+                <a:solidFill>
+                  <a:srgbClr val="4B36C7"/>
+                </a:solidFill>
+                <a:latin typeface="Helvetica" pitchFamily="34" charset="0"/>
+                <a:ea typeface="Helvetica" pitchFamily="34" charset="-122"/>
+                <a:cs typeface="Helvetica" pitchFamily="34" charset="-120"/>
+              </a:rPr>
+              <a:t>◆  TIP — CLAUDE IN CHROME: SPREADSHEET TANPA COPY-PASTE</a:t>
+            </a:r>
+            <a:endParaRPr lang="en-US" sz="1250" dirty="0"/>
+          </a:p>
+        </p:txBody>
+      </p:sp>
+      <p:sp>
+        <p:nvSpPr>
+          <p:cNvPr id="13" name="Text 11"/>
+          <p:cNvSpPr/>
+          <p:nvPr/>
+        </p:nvSpPr>
+        <p:spPr>
+          <a:xfrm>
+            <a:off x="749808" y="4327931"/>
+            <a:ext cx="10692079" cy="487045"/>
+          </a:xfrm>
+          <a:prstGeom prst="rect">
+            <a:avLst/>
+          </a:prstGeom>
+          <a:noFill/>
+          <a:ln/>
+        </p:spPr>
+        <p:txBody>
+          <a:bodyPr wrap="square" lIns="0" tIns="0" rIns="0" bIns="0" rtlCol="0" anchor="t"/>
+          <a:lstStyle/>
+          <a:p>
+            <a:pPr indent="0" marL="0">
+              <a:lnSpc>
+                <a:spcPct val="130000"/>
+              </a:lnSpc>
+              <a:buNone/>
+            </a:pPr>
+            <a:r>
+              <a:rPr lang="en-US" sz="1250" dirty="0">
+                <a:solidFill>
+                  <a:srgbClr val="23283A"/>
+                </a:solidFill>
+                <a:latin typeface="Helvetica" pitchFamily="34" charset="0"/>
+                <a:ea typeface="Helvetica" pitchFamily="34" charset="-122"/>
+                <a:cs typeface="Helvetica" pitchFamily="34" charset="-120"/>
+              </a:rPr>
+              <a:t>Baca &amp; isi formula langsung di Google Sheets (dan Excel Online) tanpa copy-paste. Butuh paket Pro atau lebih tinggi — tidak tersedia di Free. Install "Claude for Chrome" dari Chrome Web Store → login → buka Sheets/Excel Online → klik ikon Claude di toolbar.</a:t>
+            </a:r>
+            <a:endParaRPr lang="en-US" sz="1250" dirty="0"/>
           </a:p>
         </p:txBody>
       </p:sp>

</xml_diff>

<commit_message>
K2 M4: merge Alur Prompt into Latihan with concrete download/upload/drag-drop steps, remove Level Up Dashboard section, restyle Apps Script menu list from numbered steps to plain tier cards (they're menu items, not sequential steps), relocate Claude in Chrome tip to bottom
</commit_message>
<xml_diff>
--- a/K2-Produktivitas/M04-Google-Sheets/K2-M04-Google-Sheets.pptx
+++ b/K2-Produktivitas/M04-Google-Sheets/K2-M04-Google-Sheets.pptx
@@ -11,10 +11,9 @@
     <p:sldId id="259" r:id="rId5"/>
     <p:sldId id="260" r:id="rId6"/>
     <p:sldId id="261" r:id="rId7"/>
-    <p:sldId id="262" r:id="rId8"/>
   </p:sldIdLst>
   <p:notesMasterIdLst>
-    <p:notesMasterId r:id="rId9"/>
+    <p:notesMasterId r:id="rId8"/>
   </p:notesMasterIdLst>
   <p:sldSz cx="12191695" cy="6858000"/>
   <p:notesSz cx="6858000" cy="12191695"/>
@@ -972,94 +971,6 @@
             <a:fld id="{F7021451-1387-4CA6-816F-3879F97B5CBC}" type="slidenum">
               <a:rPr lang="en-US"/>
               <a:t>6</a:t>
-            </a:fld>
-            <a:endParaRPr lang="en-US"/>
-          </a:p>
-        </p:txBody>
-      </p:sp>
-    </p:spTree>
-    <p:extLst>
-      <p:ext uri="{BB962C8B-B14F-4D97-AF65-F5344CB8AC3E}">
-        <p14:creationId xmlns:p14="http://schemas.microsoft.com/office/powerpoint/2010/main" val="1024086991"/>
-      </p:ext>
-    </p:extLst>
-  </p:cSld>
-  <p:clrMapOvr>
-    <a:masterClrMapping/>
-  </p:clrMapOvr>
-</p:notes>
-</file>
-
-<file path=ppt/notesSlides/notesSlide7.xml><?xml version="1.0" encoding="utf-8"?>
-<p:notes xmlns:a="http://schemas.openxmlformats.org/drawingml/2006/main" xmlns:r="http://schemas.openxmlformats.org/officeDocument/2006/relationships" xmlns:p="http://schemas.openxmlformats.org/presentationml/2006/main">
-  <p:cSld>
-    <p:spTree>
-      <p:nvGrpSpPr>
-        <p:cNvPr id="1" name=""/>
-        <p:cNvGrpSpPr/>
-        <p:nvPr/>
-      </p:nvGrpSpPr>
-      <p:grpSpPr>
-        <a:xfrm>
-          <a:off x="0" y="0"/>
-          <a:ext cx="0" cy="0"/>
-          <a:chOff x="0" y="0"/>
-          <a:chExt cx="0" cy="0"/>
-        </a:xfrm>
-      </p:grpSpPr>
-      <p:sp>
-        <p:nvSpPr>
-          <p:cNvPr id="2" name="Slide Image Placeholder 1"/>
-          <p:cNvSpPr>
-            <a:spLocks noGrp="1" noRot="1" noChangeAspect="1"/>
-          </p:cNvSpPr>
-          <p:nvPr>
-            <p:ph type="sldImg"/>
-          </p:nvPr>
-        </p:nvSpPr>
-        <p:spPr/>
-      </p:sp>
-      <p:sp>
-        <p:nvSpPr>
-          <p:cNvPr id="3" name="Notes Placeholder 2"/>
-          <p:cNvSpPr>
-            <a:spLocks noGrp="1"/>
-          </p:cNvSpPr>
-          <p:nvPr>
-            <p:ph type="body" idx="1"/>
-          </p:nvPr>
-        </p:nvSpPr>
-        <p:spPr/>
-        <p:txBody>
-          <a:bodyPr/>
-          <a:lstStyle/>
-          <a:p>
-            <a:r>
-              <a:rPr lang="en-US" dirty="0"/>
-              <a:t/>
-            </a:r>
-            <a:endParaRPr lang="en-US" dirty="0"/>
-          </a:p>
-        </p:txBody>
-      </p:sp>
-      <p:sp>
-        <p:nvSpPr>
-          <p:cNvPr id="4" name="Slide Number Placeholder 3"/>
-          <p:cNvSpPr>
-            <a:spLocks noGrp="1"/>
-          </p:cNvSpPr>
-          <p:nvPr>
-            <p:ph type="sldNum" sz="quarter" idx="10"/>
-          </p:nvPr>
-        </p:nvSpPr>
-        <p:spPr/>
-        <p:txBody>
-          <a:bodyPr/>
-          <a:lstStyle/>
-          <a:p>
-            <a:fld id="{F7021451-1387-4CA6-816F-3879F97B5CBC}" type="slidenum">
-              <a:rPr lang="en-US"/>
-              <a:t>7</a:t>
             </a:fld>
             <a:endParaRPr lang="en-US"/>
           </a:p>
@@ -3226,7 +3137,7 @@
                 <a:ea typeface="Helvetica" pitchFamily="34" charset="-122"/>
                 <a:cs typeface="Helvetica" pitchFamily="34" charset="-120"/>
               </a:rPr>
-              <a:t>Alur Prompt: Data → Keputusan</a:t>
+              <a:t>Latihan — Langkah demi Langkah</a:t>
             </a:r>
             <a:endParaRPr lang="en-US" sz="2200" dirty="0"/>
           </a:p>
@@ -3265,7 +3176,7 @@
                 <a:ea typeface="Helvetica" pitchFamily="34" charset="-122"/>
                 <a:cs typeface="Helvetica" pitchFamily="34" charset="-120"/>
               </a:rPr>
-              <a:t>3 LANGKAH DARI DATA KE FILE SIAP DIBAGIKAN</a:t>
+              <a:t>PRAKTIK LANGSUNG DENGAN DATA KASUAL STUDIO</a:t>
             </a:r>
             <a:endParaRPr lang="en-US" sz="1250" dirty="0"/>
           </a:p>
@@ -3280,11 +3191,11 @@
         <p:spPr>
           <a:xfrm>
             <a:off x="548640" y="2112264"/>
-            <a:ext cx="3527450" cy="1700540"/>
+            <a:ext cx="3527450" cy="1481145"/>
           </a:xfrm>
           <a:prstGeom prst="roundRect">
             <a:avLst>
-              <a:gd name="adj" fmla="val 5377"/>
+              <a:gd name="adj" fmla="val 6174"/>
             </a:avLst>
           </a:prstGeom>
           <a:solidFill>
@@ -3390,7 +3301,7 @@
                 <a:ea typeface="Helvetica" pitchFamily="34" charset="-122"/>
                 <a:cs typeface="Helvetica" pitchFamily="34" charset="-120"/>
               </a:rPr>
-              <a:t>Formula</a:t>
+              <a:t>Download File</a:t>
             </a:r>
             <a:endParaRPr lang="en-US" sz="1400" dirty="0"/>
           </a:p>
@@ -3405,7 +3316,7 @@
         <p:spPr>
           <a:xfrm>
             <a:off x="749808" y="2734056"/>
-            <a:ext cx="3125114" cy="877580"/>
+            <a:ext cx="3125114" cy="658185"/>
           </a:xfrm>
           <a:prstGeom prst="rect">
             <a:avLst/>
@@ -3432,7 +3343,7 @@
                 <a:ea typeface="Helvetica" pitchFamily="34" charset="-122"/>
                 <a:cs typeface="Helvetica" pitchFamily="34" charset="-120"/>
               </a:rPr>
-              <a:t>"Data saya kolom: Tanggal, Order ID, Produk, Region, Sales, Qty, Harga Satuan, Total. Buatkan formula SUMIF total revenue per Produk dan per Region."</a:t>
+              <a:t>Download k2-data-latihan-sheets.csv dari halaman materi — data transaksi Kasual Studio, ~180 baris.</a:t>
             </a:r>
             <a:endParaRPr lang="en-US" sz="1200" dirty="0"/>
           </a:p>
@@ -3447,11 +3358,11 @@
         <p:spPr>
           <a:xfrm>
             <a:off x="4332122" y="2112264"/>
-            <a:ext cx="3527450" cy="1700540"/>
+            <a:ext cx="3527450" cy="1481145"/>
           </a:xfrm>
           <a:prstGeom prst="roundRect">
             <a:avLst>
-              <a:gd name="adj" fmla="val 5377"/>
+              <a:gd name="adj" fmla="val 6174"/>
             </a:avLst>
           </a:prstGeom>
           <a:solidFill>
@@ -3557,7 +3468,7 @@
                 <a:ea typeface="Helvetica" pitchFamily="34" charset="-122"/>
                 <a:cs typeface="Helvetica" pitchFamily="34" charset="-120"/>
               </a:rPr>
-              <a:t>Analisis &amp; Rekomendasi</a:t>
+              <a:t>Upload ke Claude</a:t>
             </a:r>
             <a:endParaRPr lang="en-US" sz="1400" dirty="0"/>
           </a:p>
@@ -3572,7 +3483,7 @@
         <p:spPr>
           <a:xfrm>
             <a:off x="4533290" y="2734056"/>
-            <a:ext cx="3125114" cy="877580"/>
+            <a:ext cx="3125114" cy="658185"/>
           </a:xfrm>
           <a:prstGeom prst="rect">
             <a:avLst/>
@@ -3599,7 +3510,7 @@
                 <a:ea typeface="Helvetica" pitchFamily="34" charset="-122"/>
                 <a:cs typeface="Helvetica" pitchFamily="34" charset="-120"/>
               </a:rPr>
-              <a:t>"Ini data transaksi beberapa bulan terakhir: [paste]. Produk/region mana paling laris? Ada tren naik-turun? Kasih rekomendasi."</a:t>
+              <a:t>Buka claude.ai, chat baru. Drag &amp; drop file CSV ke jendela chat (atau klik ikon attach).</a:t>
             </a:r>
             <a:endParaRPr lang="en-US" sz="1200" dirty="0"/>
           </a:p>
@@ -3614,11 +3525,11 @@
         <p:spPr>
           <a:xfrm>
             <a:off x="8115605" y="2112264"/>
-            <a:ext cx="3527450" cy="1700540"/>
+            <a:ext cx="3527450" cy="1481145"/>
           </a:xfrm>
           <a:prstGeom prst="roundRect">
             <a:avLst>
-              <a:gd name="adj" fmla="val 5377"/>
+              <a:gd name="adj" fmla="val 6174"/>
             </a:avLst>
           </a:prstGeom>
           <a:solidFill>
@@ -3724,7 +3635,7 @@
                 <a:ea typeface="Helvetica" pitchFamily="34" charset="-122"/>
                 <a:cs typeface="Helvetica" pitchFamily="34" charset="-120"/>
               </a:rPr>
-              <a:t>File Excel Ringkasan</a:t>
+              <a:t>Kirim 3 Prompt</a:t>
             </a:r>
             <a:endParaRPr lang="en-US" sz="1400" dirty="0"/>
           </a:p>
@@ -3739,7 +3650,7 @@
         <p:spPr>
           <a:xfrm>
             <a:off x="8316773" y="2734056"/>
-            <a:ext cx="3125114" cy="877580"/>
+            <a:ext cx="3125114" cy="658185"/>
           </a:xfrm>
           <a:prstGeom prst="rect">
             <a:avLst/>
@@ -3766,7 +3677,7 @@
                 <a:ea typeface="Helvetica" pitchFamily="34" charset="-122"/>
                 <a:cs typeface="Helvetica" pitchFamily="34" charset="-120"/>
               </a:rPr>
-              <a:t>"Dari analisis tadi, buatkan file Excel ringkasan: per produk, per region, plus insight &amp; rekomendasi — siap dibagikan ke tim."</a:t>
+              <a:t>Kirim 3 prompt berikut satu per satu di chat yang sama — Claude tetap ingat datamu.</a:t>
             </a:r>
             <a:endParaRPr lang="en-US" sz="1200" dirty="0"/>
           </a:p>
@@ -3774,14 +3685,119 @@
       </p:sp>
       <p:sp>
         <p:nvSpPr>
-          <p:cNvPr id="23" name="Text 21"/>
-          <p:cNvSpPr/>
-          <p:nvPr/>
-        </p:nvSpPr>
-        <p:spPr>
-          <a:xfrm>
-            <a:off x="548640" y="4050548"/>
-            <a:ext cx="11094415" cy="498734"/>
+          <p:cNvPr id="23" name="Shape 21"/>
+          <p:cNvSpPr/>
+          <p:nvPr/>
+        </p:nvSpPr>
+        <p:spPr>
+          <a:xfrm>
+            <a:off x="548640" y="3831153"/>
+            <a:ext cx="11094415" cy="1836776"/>
+          </a:xfrm>
+          <a:prstGeom prst="roundRect">
+            <a:avLst>
+              <a:gd name="adj" fmla="val 4978"/>
+            </a:avLst>
+          </a:prstGeom>
+          <a:solidFill>
+            <a:srgbClr val="141D33"/>
+          </a:solidFill>
+          <a:ln w="12700">
+            <a:solidFill>
+              <a:srgbClr val="6849F6"/>
+            </a:solidFill>
+            <a:prstDash val="solid"/>
+          </a:ln>
+        </p:spPr>
+      </p:sp>
+      <p:sp>
+        <p:nvSpPr>
+          <p:cNvPr id="24" name="Text 22"/>
+          <p:cNvSpPr/>
+          <p:nvPr/>
+        </p:nvSpPr>
+        <p:spPr>
+          <a:xfrm>
+            <a:off x="768096" y="4050609"/>
+            <a:ext cx="10655503" cy="256032"/>
+          </a:xfrm>
+          <a:prstGeom prst="rect">
+            <a:avLst/>
+          </a:prstGeom>
+          <a:noFill/>
+          <a:ln/>
+        </p:spPr>
+        <p:txBody>
+          <a:bodyPr wrap="square" lIns="0" tIns="0" rIns="0" bIns="0" rtlCol="0" anchor="ctr"/>
+          <a:lstStyle/>
+          <a:p>
+            <a:pPr indent="0" marL="0">
+              <a:buNone/>
+            </a:pPr>
+            <a:r>
+              <a:rPr lang="en-US" sz="1150" b="1" spc="30" kern="0" dirty="0">
+                <a:solidFill>
+                  <a:srgbClr val="8B7CF6"/>
+                </a:solidFill>
+                <a:latin typeface="Helvetica" pitchFamily="34" charset="0"/>
+                <a:ea typeface="Helvetica" pitchFamily="34" charset="-122"/>
+                <a:cs typeface="Helvetica" pitchFamily="34" charset="-120"/>
+              </a:rPr>
+              <a:t>PROMPT YANG DIKIRIM</a:t>
+            </a:r>
+            <a:endParaRPr lang="en-US" sz="1150" dirty="0"/>
+          </a:p>
+        </p:txBody>
+      </p:sp>
+      <p:sp>
+        <p:nvSpPr>
+          <p:cNvPr id="25" name="Text 23"/>
+          <p:cNvSpPr/>
+          <p:nvPr/>
+        </p:nvSpPr>
+        <p:spPr>
+          <a:xfrm>
+            <a:off x="768096" y="4398081"/>
+            <a:ext cx="10655503" cy="219456"/>
+          </a:xfrm>
+          <a:prstGeom prst="rect">
+            <a:avLst/>
+          </a:prstGeom>
+          <a:noFill/>
+          <a:ln/>
+        </p:spPr>
+        <p:txBody>
+          <a:bodyPr wrap="square" lIns="0" tIns="0" rIns="0" bIns="0" rtlCol="0" anchor="ctr"/>
+          <a:lstStyle/>
+          <a:p>
+            <a:pPr indent="0" marL="0">
+              <a:buNone/>
+            </a:pPr>
+            <a:r>
+              <a:rPr lang="en-US" sz="1150" b="1" dirty="0">
+                <a:solidFill>
+                  <a:srgbClr val="FFFFFF"/>
+                </a:solidFill>
+                <a:latin typeface="Helvetica" pitchFamily="34" charset="0"/>
+                <a:ea typeface="Helvetica" pitchFamily="34" charset="-122"/>
+                <a:cs typeface="Helvetica" pitchFamily="34" charset="-120"/>
+              </a:rPr>
+              <a:t>Prompt 1 — Formula</a:t>
+            </a:r>
+            <a:endParaRPr lang="en-US" sz="1150" dirty="0"/>
+          </a:p>
+        </p:txBody>
+      </p:sp>
+      <p:sp>
+        <p:nvSpPr>
+          <p:cNvPr id="26" name="Text 24"/>
+          <p:cNvSpPr/>
+          <p:nvPr/>
+        </p:nvSpPr>
+        <p:spPr>
+          <a:xfrm>
+            <a:off x="768096" y="4654113"/>
+            <a:ext cx="10655503" cy="214300"/>
           </a:xfrm>
           <a:prstGeom prst="rect">
             <a:avLst/>
@@ -3795,22 +3811,103 @@
           <a:p>
             <a:pPr indent="0" marL="0">
               <a:lnSpc>
-                <a:spcPct val="128000"/>
+                <a:spcPct val="130000"/>
               </a:lnSpc>
               <a:buNone/>
             </a:pPr>
             <a:r>
-              <a:rPr lang="en-US" sz="1300" dirty="0">
-                <a:solidFill>
-                  <a:srgbClr val="6B7280"/>
-                </a:solidFill>
-                <a:latin typeface="Helvetica" pitchFamily="34" charset="0"/>
-                <a:ea typeface="Helvetica" pitchFamily="34" charset="-122"/>
-                <a:cs typeface="Helvetica" pitchFamily="34" charset="-120"/>
-              </a:rPr>
-              <a:t>Tips: Step 2 dan 3 adalah dua deliverable berbeda dari satu alur — rekomendasi di chat untuk keputusan cepat, file Excel untuk yang perlu dibagikan ke orang lain.</a:t>
-            </a:r>
-            <a:endParaRPr lang="en-US" sz="1300" dirty="0"/>
+              <a:rPr lang="en-US" sz="1100" dirty="0">
+                <a:solidFill>
+                  <a:srgbClr val="C7CDE0"/>
+                </a:solidFill>
+                <a:latin typeface="Helvetica" pitchFamily="34" charset="0"/>
+                <a:ea typeface="Helvetica" pitchFamily="34" charset="-122"/>
+                <a:cs typeface="Helvetica" pitchFamily="34" charset="-120"/>
+              </a:rPr>
+              <a:t>"Data saya kolom: Tanggal, Order ID, Produk, Region, Sales, Qty, Harga Satuan, Total. Buatkan formula SUMIF total revenue per Produk dan per Region."</a:t>
+            </a:r>
+            <a:endParaRPr lang="en-US" sz="1100" dirty="0"/>
+          </a:p>
+        </p:txBody>
+      </p:sp>
+      <p:sp>
+        <p:nvSpPr>
+          <p:cNvPr id="27" name="Text 25"/>
+          <p:cNvSpPr/>
+          <p:nvPr/>
+        </p:nvSpPr>
+        <p:spPr>
+          <a:xfrm>
+            <a:off x="768096" y="4978141"/>
+            <a:ext cx="10655503" cy="219456"/>
+          </a:xfrm>
+          <a:prstGeom prst="rect">
+            <a:avLst/>
+          </a:prstGeom>
+          <a:noFill/>
+          <a:ln/>
+        </p:spPr>
+        <p:txBody>
+          <a:bodyPr wrap="square" lIns="0" tIns="0" rIns="0" bIns="0" rtlCol="0" anchor="ctr"/>
+          <a:lstStyle/>
+          <a:p>
+            <a:pPr indent="0" marL="0">
+              <a:buNone/>
+            </a:pPr>
+            <a:r>
+              <a:rPr lang="en-US" sz="1150" b="1" dirty="0">
+                <a:solidFill>
+                  <a:srgbClr val="FFFFFF"/>
+                </a:solidFill>
+                <a:latin typeface="Helvetica" pitchFamily="34" charset="0"/>
+                <a:ea typeface="Helvetica" pitchFamily="34" charset="-122"/>
+                <a:cs typeface="Helvetica" pitchFamily="34" charset="-120"/>
+              </a:rPr>
+              <a:t>Prompt 2 — Analisis &amp; Rekomendasi</a:t>
+            </a:r>
+            <a:endParaRPr lang="en-US" sz="1150" dirty="0"/>
+          </a:p>
+        </p:txBody>
+      </p:sp>
+      <p:sp>
+        <p:nvSpPr>
+          <p:cNvPr id="28" name="Text 26"/>
+          <p:cNvSpPr/>
+          <p:nvPr/>
+        </p:nvSpPr>
+        <p:spPr>
+          <a:xfrm>
+            <a:off x="768096" y="5234173"/>
+            <a:ext cx="10655503" cy="214300"/>
+          </a:xfrm>
+          <a:prstGeom prst="rect">
+            <a:avLst/>
+          </a:prstGeom>
+          <a:noFill/>
+          <a:ln/>
+        </p:spPr>
+        <p:txBody>
+          <a:bodyPr wrap="square" lIns="0" tIns="0" rIns="0" bIns="0" rtlCol="0" anchor="t"/>
+          <a:lstStyle/>
+          <a:p>
+            <a:pPr indent="0" marL="0">
+              <a:lnSpc>
+                <a:spcPct val="130000"/>
+              </a:lnSpc>
+              <a:buNone/>
+            </a:pPr>
+            <a:r>
+              <a:rPr lang="en-US" sz="1100" dirty="0">
+                <a:solidFill>
+                  <a:srgbClr val="C7CDE0"/>
+                </a:solidFill>
+                <a:latin typeface="Helvetica" pitchFamily="34" charset="0"/>
+                <a:ea typeface="Helvetica" pitchFamily="34" charset="-122"/>
+                <a:cs typeface="Helvetica" pitchFamily="34" charset="-120"/>
+              </a:rPr>
+              <a:t>"Dari data transaksi ini: produk/region mana paling laris? Ada tren naik-turun? Sales mana paling produktif? Kasih rekomendasi."</a:t>
+            </a:r>
+            <a:endParaRPr lang="en-US" sz="1100" dirty="0"/>
           </a:p>
         </p:txBody>
       </p:sp>
@@ -4011,7 +4108,7 @@
                 <a:ea typeface="Helvetica" pitchFamily="34" charset="-122"/>
                 <a:cs typeface="Helvetica" pitchFamily="34" charset="-120"/>
               </a:rPr>
-              <a:t>Latihan &amp; Output</a:t>
+              <a:t>Latihan — File Excel &amp; Output</a:t>
             </a:r>
             <a:endParaRPr lang="en-US" sz="2200" dirty="0"/>
           </a:p>
@@ -4050,7 +4147,7 @@
                 <a:ea typeface="Helvetica" pitchFamily="34" charset="-122"/>
                 <a:cs typeface="Helvetica" pitchFamily="34" charset="-120"/>
               </a:rPr>
-              <a:t>PRAKTIK LANGSUNG DENGAN DATA KAMU</a:t>
+              <a:t>PROMPT TERAKHIR: BIKIN FILE SIAP DIBAGIKAN</a:t>
             </a:r>
             <a:endParaRPr lang="en-US" sz="1250" dirty="0"/>
           </a:p>
@@ -4065,11 +4162,266 @@
         <p:spPr>
           <a:xfrm>
             <a:off x="548640" y="2112264"/>
-            <a:ext cx="11094415" cy="1480376"/>
+            <a:ext cx="11094415" cy="1256716"/>
           </a:xfrm>
           <a:prstGeom prst="roundRect">
             <a:avLst>
-              <a:gd name="adj" fmla="val 6177"/>
+              <a:gd name="adj" fmla="val 7276"/>
+            </a:avLst>
+          </a:prstGeom>
+          <a:solidFill>
+            <a:srgbClr val="141D33"/>
+          </a:solidFill>
+          <a:ln w="12700">
+            <a:solidFill>
+              <a:srgbClr val="6849F6"/>
+            </a:solidFill>
+            <a:prstDash val="solid"/>
+          </a:ln>
+        </p:spPr>
+      </p:sp>
+      <p:sp>
+        <p:nvSpPr>
+          <p:cNvPr id="9" name="Text 7"/>
+          <p:cNvSpPr/>
+          <p:nvPr/>
+        </p:nvSpPr>
+        <p:spPr>
+          <a:xfrm>
+            <a:off x="768096" y="2331720"/>
+            <a:ext cx="10655503" cy="256032"/>
+          </a:xfrm>
+          <a:prstGeom prst="rect">
+            <a:avLst/>
+          </a:prstGeom>
+          <a:noFill/>
+          <a:ln/>
+        </p:spPr>
+        <p:txBody>
+          <a:bodyPr wrap="square" lIns="0" tIns="0" rIns="0" bIns="0" rtlCol="0" anchor="ctr"/>
+          <a:lstStyle/>
+          <a:p>
+            <a:pPr indent="0" marL="0">
+              <a:buNone/>
+            </a:pPr>
+            <a:r>
+              <a:rPr lang="en-US" sz="1150" b="1" spc="30" kern="0" dirty="0">
+                <a:solidFill>
+                  <a:srgbClr val="8B7CF6"/>
+                </a:solidFill>
+                <a:latin typeface="Helvetica" pitchFamily="34" charset="0"/>
+                <a:ea typeface="Helvetica" pitchFamily="34" charset="-122"/>
+                <a:cs typeface="Helvetica" pitchFamily="34" charset="-120"/>
+              </a:rPr>
+              <a:t>PROMPT YANG DIKIRIM</a:t>
+            </a:r>
+            <a:endParaRPr lang="en-US" sz="1150" dirty="0"/>
+          </a:p>
+        </p:txBody>
+      </p:sp>
+      <p:sp>
+        <p:nvSpPr>
+          <p:cNvPr id="10" name="Text 8"/>
+          <p:cNvSpPr/>
+          <p:nvPr/>
+        </p:nvSpPr>
+        <p:spPr>
+          <a:xfrm>
+            <a:off x="768096" y="2679192"/>
+            <a:ext cx="10655503" cy="219456"/>
+          </a:xfrm>
+          <a:prstGeom prst="rect">
+            <a:avLst/>
+          </a:prstGeom>
+          <a:noFill/>
+          <a:ln/>
+        </p:spPr>
+        <p:txBody>
+          <a:bodyPr wrap="square" lIns="0" tIns="0" rIns="0" bIns="0" rtlCol="0" anchor="ctr"/>
+          <a:lstStyle/>
+          <a:p>
+            <a:pPr indent="0" marL="0">
+              <a:buNone/>
+            </a:pPr>
+            <a:r>
+              <a:rPr lang="en-US" sz="1150" b="1" dirty="0">
+                <a:solidFill>
+                  <a:srgbClr val="FFFFFF"/>
+                </a:solidFill>
+                <a:latin typeface="Helvetica" pitchFamily="34" charset="0"/>
+                <a:ea typeface="Helvetica" pitchFamily="34" charset="-122"/>
+                <a:cs typeface="Helvetica" pitchFamily="34" charset="-120"/>
+              </a:rPr>
+              <a:t>Prompt 3 — File Excel Ringkasan</a:t>
+            </a:r>
+            <a:endParaRPr lang="en-US" sz="1150" dirty="0"/>
+          </a:p>
+        </p:txBody>
+      </p:sp>
+      <p:sp>
+        <p:nvSpPr>
+          <p:cNvPr id="11" name="Text 9"/>
+          <p:cNvSpPr/>
+          <p:nvPr/>
+        </p:nvSpPr>
+        <p:spPr>
+          <a:xfrm>
+            <a:off x="768096" y="2935224"/>
+            <a:ext cx="10655503" cy="214300"/>
+          </a:xfrm>
+          <a:prstGeom prst="rect">
+            <a:avLst/>
+          </a:prstGeom>
+          <a:noFill/>
+          <a:ln/>
+        </p:spPr>
+        <p:txBody>
+          <a:bodyPr wrap="square" lIns="0" tIns="0" rIns="0" bIns="0" rtlCol="0" anchor="t"/>
+          <a:lstStyle/>
+          <a:p>
+            <a:pPr indent="0" marL="0">
+              <a:lnSpc>
+                <a:spcPct val="130000"/>
+              </a:lnSpc>
+              <a:buNone/>
+            </a:pPr>
+            <a:r>
+              <a:rPr lang="en-US" sz="1100" dirty="0">
+                <a:solidFill>
+                  <a:srgbClr val="C7CDE0"/>
+                </a:solidFill>
+                <a:latin typeface="Helvetica" pitchFamily="34" charset="0"/>
+                <a:ea typeface="Helvetica" pitchFamily="34" charset="-122"/>
+                <a:cs typeface="Helvetica" pitchFamily="34" charset="-120"/>
+              </a:rPr>
+              <a:t>"Dari analisis dan rekomendasi tadi, buatkan file Excel ringkasan: per produk, per region, plus insight &amp; rekomendasi — siap dibagikan ke tim."</a:t>
+            </a:r>
+            <a:endParaRPr lang="en-US" sz="1100" dirty="0"/>
+          </a:p>
+        </p:txBody>
+      </p:sp>
+      <p:sp>
+        <p:nvSpPr>
+          <p:cNvPr id="12" name="Shape 10"/>
+          <p:cNvSpPr/>
+          <p:nvPr/>
+        </p:nvSpPr>
+        <p:spPr>
+          <a:xfrm>
+            <a:off x="548640" y="3606724"/>
+            <a:ext cx="11094415" cy="1236853"/>
+          </a:xfrm>
+          <a:prstGeom prst="roundRect">
+            <a:avLst>
+              <a:gd name="adj" fmla="val 7393"/>
+            </a:avLst>
+          </a:prstGeom>
+          <a:solidFill>
+            <a:srgbClr val="F3F0FF"/>
+          </a:solidFill>
+          <a:ln w="12700">
+            <a:solidFill>
+              <a:srgbClr val="DCD3FB"/>
+            </a:solidFill>
+            <a:prstDash val="solid"/>
+          </a:ln>
+        </p:spPr>
+      </p:sp>
+      <p:sp>
+        <p:nvSpPr>
+          <p:cNvPr id="13" name="Text 11"/>
+          <p:cNvSpPr/>
+          <p:nvPr/>
+        </p:nvSpPr>
+        <p:spPr>
+          <a:xfrm>
+            <a:off x="749808" y="3807892"/>
+            <a:ext cx="10692079" cy="274320"/>
+          </a:xfrm>
+          <a:prstGeom prst="rect">
+            <a:avLst/>
+          </a:prstGeom>
+          <a:noFill/>
+          <a:ln/>
+        </p:spPr>
+        <p:txBody>
+          <a:bodyPr wrap="square" lIns="0" tIns="0" rIns="0" bIns="0" rtlCol="0" anchor="ctr"/>
+          <a:lstStyle/>
+          <a:p>
+            <a:pPr indent="0" marL="0">
+              <a:buNone/>
+            </a:pPr>
+            <a:r>
+              <a:rPr lang="en-US" sz="1250" b="1" spc="30" kern="0" dirty="0">
+                <a:solidFill>
+                  <a:srgbClr val="4B36C7"/>
+                </a:solidFill>
+                <a:latin typeface="Helvetica" pitchFamily="34" charset="0"/>
+                <a:ea typeface="Helvetica" pitchFamily="34" charset="-122"/>
+                <a:cs typeface="Helvetica" pitchFamily="34" charset="-120"/>
+              </a:rPr>
+              <a:t>◆  TIP</a:t>
+            </a:r>
+            <a:endParaRPr lang="en-US" sz="1250" dirty="0"/>
+          </a:p>
+        </p:txBody>
+      </p:sp>
+      <p:sp>
+        <p:nvSpPr>
+          <p:cNvPr id="14" name="Text 12"/>
+          <p:cNvSpPr/>
+          <p:nvPr/>
+        </p:nvSpPr>
+        <p:spPr>
+          <a:xfrm>
+            <a:off x="749808" y="4155364"/>
+            <a:ext cx="10692079" cy="487045"/>
+          </a:xfrm>
+          <a:prstGeom prst="rect">
+            <a:avLst/>
+          </a:prstGeom>
+          <a:noFill/>
+          <a:ln/>
+        </p:spPr>
+        <p:txBody>
+          <a:bodyPr wrap="square" lIns="0" tIns="0" rIns="0" bIns="0" rtlCol="0" anchor="t"/>
+          <a:lstStyle/>
+          <a:p>
+            <a:pPr indent="0" marL="0">
+              <a:lnSpc>
+                <a:spcPct val="130000"/>
+              </a:lnSpc>
+              <a:buNone/>
+            </a:pPr>
+            <a:r>
+              <a:rPr lang="en-US" sz="1250" dirty="0">
+                <a:solidFill>
+                  <a:srgbClr val="23283A"/>
+                </a:solidFill>
+                <a:latin typeface="Helvetica" pitchFamily="34" charset="0"/>
+                <a:ea typeface="Helvetica" pitchFamily="34" charset="-122"/>
+                <a:cs typeface="Helvetica" pitchFamily="34" charset="-120"/>
+              </a:rPr>
+              <a:t>Prompt 1 hasilnya formula — salin manual ke sheet-mu. Prompt 3 beda: Claude langsung generate file .xlsx yang muncul sebagai lampiran di chat, tinggal download.</a:t>
+            </a:r>
+            <a:endParaRPr lang="en-US" sz="1250" dirty="0"/>
+          </a:p>
+        </p:txBody>
+      </p:sp>
+      <p:sp>
+        <p:nvSpPr>
+          <p:cNvPr id="15" name="Shape 13"/>
+          <p:cNvSpPr/>
+          <p:nvPr/>
+        </p:nvSpPr>
+        <p:spPr>
+          <a:xfrm>
+            <a:off x="548640" y="5081321"/>
+            <a:ext cx="11094415" cy="993331"/>
+          </a:xfrm>
+          <a:prstGeom prst="roundRect">
+            <a:avLst>
+              <a:gd name="adj" fmla="val 9205"/>
             </a:avLst>
           </a:prstGeom>
           <a:solidFill>
@@ -4085,13 +4437,13 @@
       </p:sp>
       <p:sp>
         <p:nvSpPr>
-          <p:cNvPr id="9" name="Text 7"/>
-          <p:cNvSpPr/>
-          <p:nvPr/>
-        </p:nvSpPr>
-        <p:spPr>
-          <a:xfrm>
-            <a:off x="749808" y="2313432"/>
+          <p:cNvPr id="16" name="Text 14"/>
+          <p:cNvSpPr/>
+          <p:nvPr/>
+        </p:nvSpPr>
+        <p:spPr>
+          <a:xfrm>
+            <a:off x="749808" y="5282489"/>
             <a:ext cx="10692079" cy="274320"/>
           </a:xfrm>
           <a:prstGeom prst="rect">
@@ -4116,7 +4468,7 @@
                 <a:ea typeface="Helvetica" pitchFamily="34" charset="-122"/>
                 <a:cs typeface="Helvetica" pitchFamily="34" charset="-120"/>
               </a:rPr>
-              <a:t>■  LATIHAN</a:t>
+              <a:t>■  OUTPUT</a:t>
             </a:r>
             <a:endParaRPr lang="en-US" sz="1250" dirty="0"/>
           </a:p>
@@ -4124,14 +4476,14 @@
       </p:sp>
       <p:sp>
         <p:nvSpPr>
-          <p:cNvPr id="10" name="Text 8"/>
-          <p:cNvSpPr/>
-          <p:nvPr/>
-        </p:nvSpPr>
-        <p:spPr>
-          <a:xfrm>
-            <a:off x="749808" y="2660904"/>
-            <a:ext cx="10692079" cy="730568"/>
+          <p:cNvPr id="17" name="Text 15"/>
+          <p:cNvSpPr/>
+          <p:nvPr/>
+        </p:nvSpPr>
+        <p:spPr>
+          <a:xfrm>
+            <a:off x="749808" y="5629961"/>
+            <a:ext cx="10692079" cy="243523"/>
           </a:xfrm>
           <a:prstGeom prst="rect">
             <a:avLst/>
@@ -4158,196 +4510,7 @@
                 <a:ea typeface="Helvetica" pitchFamily="34" charset="-122"/>
                 <a:cs typeface="Helvetica" pitchFamily="34" charset="-120"/>
               </a:rPr>
-              <a:t>Download k2-data-latihan-sheets.csv — data transaksi Kasual Studio (April–Juli 2026, ~180 baris: Tanggal, Order ID, Produk, Region, Sales, Qty, Harga Satuan, Total). Minta Claude buat formula SUMIF per Produk &amp; Region. Paste contoh data, minta analisis + rekomendasi. Lalu minta file Excel ringkasannya.</a:t>
-            </a:r>
-            <a:endParaRPr lang="en-US" sz="1250" dirty="0"/>
-          </a:p>
-        </p:txBody>
-      </p:sp>
-      <p:sp>
-        <p:nvSpPr>
-          <p:cNvPr id="11" name="Shape 9"/>
-          <p:cNvSpPr/>
-          <p:nvPr/>
-        </p:nvSpPr>
-        <p:spPr>
-          <a:xfrm>
-            <a:off x="548640" y="3830384"/>
-            <a:ext cx="11094415" cy="993331"/>
-          </a:xfrm>
-          <a:prstGeom prst="roundRect">
-            <a:avLst>
-              <a:gd name="adj" fmla="val 9205"/>
-            </a:avLst>
-          </a:prstGeom>
-          <a:solidFill>
-            <a:srgbClr val="EAFAF0"/>
-          </a:solidFill>
-          <a:ln w="12700">
-            <a:solidFill>
-              <a:srgbClr val="B8E6C9"/>
-            </a:solidFill>
-            <a:prstDash val="solid"/>
-          </a:ln>
-        </p:spPr>
-      </p:sp>
-      <p:sp>
-        <p:nvSpPr>
-          <p:cNvPr id="12" name="Text 10"/>
-          <p:cNvSpPr/>
-          <p:nvPr/>
-        </p:nvSpPr>
-        <p:spPr>
-          <a:xfrm>
-            <a:off x="749808" y="4031552"/>
-            <a:ext cx="10692079" cy="274320"/>
-          </a:xfrm>
-          <a:prstGeom prst="rect">
-            <a:avLst/>
-          </a:prstGeom>
-          <a:noFill/>
-          <a:ln/>
-        </p:spPr>
-        <p:txBody>
-          <a:bodyPr wrap="square" lIns="0" tIns="0" rIns="0" bIns="0" rtlCol="0" anchor="ctr"/>
-          <a:lstStyle/>
-          <a:p>
-            <a:pPr indent="0" marL="0">
-              <a:buNone/>
-            </a:pPr>
-            <a:r>
-              <a:rPr lang="en-US" sz="1250" b="1" spc="30" kern="0" dirty="0">
-                <a:solidFill>
-                  <a:srgbClr val="1A7A44"/>
-                </a:solidFill>
-                <a:latin typeface="Helvetica" pitchFamily="34" charset="0"/>
-                <a:ea typeface="Helvetica" pitchFamily="34" charset="-122"/>
-                <a:cs typeface="Helvetica" pitchFamily="34" charset="-120"/>
-              </a:rPr>
-              <a:t>■  OUTPUT</a:t>
-            </a:r>
-            <a:endParaRPr lang="en-US" sz="1250" dirty="0"/>
-          </a:p>
-        </p:txBody>
-      </p:sp>
-      <p:sp>
-        <p:nvSpPr>
-          <p:cNvPr id="13" name="Text 11"/>
-          <p:cNvSpPr/>
-          <p:nvPr/>
-        </p:nvSpPr>
-        <p:spPr>
-          <a:xfrm>
-            <a:off x="749808" y="4379024"/>
-            <a:ext cx="10692079" cy="243523"/>
-          </a:xfrm>
-          <a:prstGeom prst="rect">
-            <a:avLst/>
-          </a:prstGeom>
-          <a:noFill/>
-          <a:ln/>
-        </p:spPr>
-        <p:txBody>
-          <a:bodyPr wrap="square" lIns="0" tIns="0" rIns="0" bIns="0" rtlCol="0" anchor="t"/>
-          <a:lstStyle/>
-          <a:p>
-            <a:pPr indent="0" marL="0">
-              <a:lnSpc>
-                <a:spcPct val="130000"/>
-              </a:lnSpc>
-              <a:buNone/>
-            </a:pPr>
-            <a:r>
-              <a:rPr lang="en-US" sz="1250" dirty="0">
-                <a:solidFill>
-                  <a:srgbClr val="23283A"/>
-                </a:solidFill>
-                <a:latin typeface="Helvetica" pitchFamily="34" charset="0"/>
-                <a:ea typeface="Helvetica" pitchFamily="34" charset="-122"/>
-                <a:cs typeface="Helvetica" pitchFamily="34" charset="-120"/>
-              </a:rPr>
-              <a:t>Formula SUMIF berjalan di sheet, insight &amp; rekomendasi dari Claude di chat, dan 1 file Excel ringkasan siap dibagikan ke tim.</a:t>
-            </a:r>
-            <a:endParaRPr lang="en-US" sz="1250" dirty="0"/>
-          </a:p>
-        </p:txBody>
-      </p:sp>
-      <p:sp>
-        <p:nvSpPr>
-          <p:cNvPr id="14" name="Text 12"/>
-          <p:cNvSpPr/>
-          <p:nvPr/>
-        </p:nvSpPr>
-        <p:spPr>
-          <a:xfrm>
-            <a:off x="548640" y="5061458"/>
-            <a:ext cx="11094415" cy="274320"/>
-          </a:xfrm>
-          <a:prstGeom prst="rect">
-            <a:avLst/>
-          </a:prstGeom>
-          <a:noFill/>
-          <a:ln/>
-        </p:spPr>
-        <p:txBody>
-          <a:bodyPr wrap="square" lIns="0" tIns="0" rIns="0" bIns="0" rtlCol="0" anchor="ctr"/>
-          <a:lstStyle/>
-          <a:p>
-            <a:pPr indent="0" marL="0">
-              <a:buNone/>
-            </a:pPr>
-            <a:r>
-              <a:rPr lang="en-US" sz="1250" b="1" spc="40" kern="0" dirty="0">
-                <a:solidFill>
-                  <a:srgbClr val="4B36C7"/>
-                </a:solidFill>
-                <a:latin typeface="Helvetica" pitchFamily="34" charset="0"/>
-                <a:ea typeface="Helvetica" pitchFamily="34" charset="-122"/>
-                <a:cs typeface="Helvetica" pitchFamily="34" charset="-120"/>
-              </a:rPr>
-              <a:t>BONUS</a:t>
-            </a:r>
-            <a:endParaRPr lang="en-US" sz="1250" dirty="0"/>
-          </a:p>
-        </p:txBody>
-      </p:sp>
-      <p:sp>
-        <p:nvSpPr>
-          <p:cNvPr id="15" name="Text 13"/>
-          <p:cNvSpPr/>
-          <p:nvPr/>
-        </p:nvSpPr>
-        <p:spPr>
-          <a:xfrm>
-            <a:off x="548640" y="5390642"/>
-            <a:ext cx="11094415" cy="479552"/>
-          </a:xfrm>
-          <a:prstGeom prst="rect">
-            <a:avLst/>
-          </a:prstGeom>
-          <a:noFill/>
-          <a:ln/>
-        </p:spPr>
-        <p:txBody>
-          <a:bodyPr wrap="square" lIns="0" tIns="0" rIns="0" bIns="0" rtlCol="0" anchor="t"/>
-          <a:lstStyle/>
-          <a:p>
-            <a:pPr indent="0" marL="0">
-              <a:lnSpc>
-                <a:spcPct val="128000"/>
-              </a:lnSpc>
-              <a:buNone/>
-            </a:pPr>
-            <a:r>
-              <a:rPr lang="en-US" sz="1250" dirty="0">
-                <a:solidFill>
-                  <a:srgbClr val="6B7280"/>
-                </a:solidFill>
-                <a:latin typeface="Helvetica" pitchFamily="34" charset="0"/>
-                <a:ea typeface="Helvetica" pitchFamily="34" charset="-122"/>
-                <a:cs typeface="Helvetica" pitchFamily="34" charset="-120"/>
-              </a:rPr>
-              <a:t>Untuk otomatisasi berulang di Google Sheets (laporan mingguan, notifikasi stok habis), Claude bisa bantu tulis Google Apps Script — lihat detailnya di slide berikut.</a:t>
+              <a:t>Formula SUMIF siap paste ke sheet-mu, insight &amp; rekomendasi di chat, dan 1 file Excel ringkasan siap download &amp; dibagikan ke tim.</a:t>
             </a:r>
             <a:endParaRPr lang="en-US" sz="1250" dirty="0"/>
           </a:p>
@@ -4705,18 +4868,381 @@
       </p:sp>
       <p:sp>
         <p:nvSpPr>
-          <p:cNvPr id="11" name="Shape 9"/>
+          <p:cNvPr id="11" name="Text 9"/>
           <p:cNvSpPr/>
           <p:nvPr/>
         </p:nvSpPr>
         <p:spPr>
           <a:xfrm>
             <a:off x="548640" y="3830384"/>
-            <a:ext cx="3527450" cy="1261750"/>
+            <a:ext cx="11094415" cy="274320"/>
+          </a:xfrm>
+          <a:prstGeom prst="rect">
+            <a:avLst/>
+          </a:prstGeom>
+          <a:noFill/>
+          <a:ln/>
+        </p:spPr>
+        <p:txBody>
+          <a:bodyPr wrap="square" lIns="0" tIns="0" rIns="0" bIns="0" rtlCol="0" anchor="ctr"/>
+          <a:lstStyle/>
+          <a:p>
+            <a:pPr indent="0" marL="0">
+              <a:buNone/>
+            </a:pPr>
+            <a:r>
+              <a:rPr lang="en-US" sz="1250" b="1" spc="40" kern="0" dirty="0">
+                <a:solidFill>
+                  <a:srgbClr val="4B36C7"/>
+                </a:solidFill>
+                <a:latin typeface="Helvetica" pitchFamily="34" charset="0"/>
+                <a:ea typeface="Helvetica" pitchFamily="34" charset="-122"/>
+                <a:cs typeface="Helvetica" pitchFamily="34" charset="-120"/>
+              </a:rPr>
+              <a:t>YANG ADA DI MENU EXPORT PDF (BUKAN LANGKAH BERURUTAN)</a:t>
+            </a:r>
+            <a:endParaRPr lang="en-US" sz="1250" dirty="0"/>
+          </a:p>
+        </p:txBody>
+      </p:sp>
+      <p:sp>
+        <p:nvSpPr>
+          <p:cNvPr id="12" name="Shape 10"/>
+          <p:cNvSpPr/>
+          <p:nvPr/>
+        </p:nvSpPr>
+        <p:spPr>
+          <a:xfrm>
+            <a:off x="548640" y="4159568"/>
+            <a:ext cx="3551834" cy="1052195"/>
           </a:xfrm>
           <a:prstGeom prst="roundRect">
             <a:avLst>
-              <a:gd name="adj" fmla="val 7247"/>
+              <a:gd name="adj" fmla="val 8690"/>
+            </a:avLst>
+          </a:prstGeom>
+          <a:solidFill>
+            <a:srgbClr val="FFFFFF"/>
+          </a:solidFill>
+          <a:ln w="12700">
+            <a:solidFill>
+              <a:srgbClr val="D6DCEB"/>
+            </a:solidFill>
+            <a:prstDash val="solid"/>
+          </a:ln>
+        </p:spPr>
+      </p:sp>
+      <p:sp>
+        <p:nvSpPr>
+          <p:cNvPr id="13" name="Text 11"/>
+          <p:cNvSpPr/>
+          <p:nvPr/>
+        </p:nvSpPr>
+        <p:spPr>
+          <a:xfrm>
+            <a:off x="713232" y="4324160"/>
+            <a:ext cx="3222650" cy="256032"/>
+          </a:xfrm>
+          <a:prstGeom prst="rect">
+            <a:avLst/>
+          </a:prstGeom>
+          <a:noFill/>
+          <a:ln/>
+        </p:spPr>
+        <p:txBody>
+          <a:bodyPr wrap="square" lIns="0" tIns="0" rIns="0" bIns="0" rtlCol="0" anchor="ctr"/>
+          <a:lstStyle/>
+          <a:p>
+            <a:pPr indent="0" marL="0">
+              <a:buNone/>
+            </a:pPr>
+            <a:r>
+              <a:rPr lang="en-US" sz="1300" b="1" dirty="0">
+                <a:solidFill>
+                  <a:srgbClr val="0D1321"/>
+                </a:solidFill>
+                <a:latin typeface="Helvetica" pitchFamily="34" charset="0"/>
+                <a:ea typeface="Helvetica" pitchFamily="34" charset="-122"/>
+                <a:cs typeface="Helvetica" pitchFamily="34" charset="-120"/>
+              </a:rPr>
+              <a:t>Rapikan &amp; Beri Judul</a:t>
+            </a:r>
+            <a:endParaRPr lang="en-US" sz="1300" dirty="0"/>
+          </a:p>
+        </p:txBody>
+      </p:sp>
+      <p:sp>
+        <p:nvSpPr>
+          <p:cNvPr id="14" name="Text 12"/>
+          <p:cNvSpPr/>
+          <p:nvPr/>
+        </p:nvSpPr>
+        <p:spPr>
+          <a:xfrm>
+            <a:off x="713232" y="4635056"/>
+            <a:ext cx="3222650" cy="412115"/>
+          </a:xfrm>
+          <a:prstGeom prst="rect">
+            <a:avLst/>
+          </a:prstGeom>
+          <a:noFill/>
+          <a:ln/>
+        </p:spPr>
+        <p:txBody>
+          <a:bodyPr wrap="square" lIns="0" tIns="0" rIns="0" bIns="0" rtlCol="0" anchor="t"/>
+          <a:lstStyle/>
+          <a:p>
+            <a:pPr indent="0" marL="0">
+              <a:lnSpc>
+                <a:spcPct val="125000"/>
+              </a:lnSpc>
+              <a:buNone/>
+            </a:pPr>
+            <a:r>
+              <a:rPr lang="en-US" sz="1100" dirty="0">
+                <a:solidFill>
+                  <a:srgbClr val="6B7280"/>
+                </a:solidFill>
+                <a:latin typeface="Helvetica" pitchFamily="34" charset="0"/>
+                <a:ea typeface="Helvetica" pitchFamily="34" charset="-122"/>
+                <a:cs typeface="Helvetica" pitchFamily="34" charset="-120"/>
+              </a:rPr>
+              <a:t>Pilih kolom hasil SUMIF → format Rupiah. Pilih data → tambah judul laporan.</a:t>
+            </a:r>
+            <a:endParaRPr lang="en-US" sz="1100" dirty="0"/>
+          </a:p>
+        </p:txBody>
+      </p:sp>
+      <p:sp>
+        <p:nvSpPr>
+          <p:cNvPr id="15" name="Shape 13"/>
+          <p:cNvSpPr/>
+          <p:nvPr/>
+        </p:nvSpPr>
+        <p:spPr>
+          <a:xfrm>
+            <a:off x="4319930" y="4159568"/>
+            <a:ext cx="3551834" cy="1052195"/>
+          </a:xfrm>
+          <a:prstGeom prst="roundRect">
+            <a:avLst>
+              <a:gd name="adj" fmla="val 8690"/>
+            </a:avLst>
+          </a:prstGeom>
+          <a:solidFill>
+            <a:srgbClr val="FFFFFF"/>
+          </a:solidFill>
+          <a:ln w="12700">
+            <a:solidFill>
+              <a:srgbClr val="D6DCEB"/>
+            </a:solidFill>
+            <a:prstDash val="solid"/>
+          </a:ln>
+        </p:spPr>
+      </p:sp>
+      <p:sp>
+        <p:nvSpPr>
+          <p:cNvPr id="16" name="Text 14"/>
+          <p:cNvSpPr/>
+          <p:nvPr/>
+        </p:nvSpPr>
+        <p:spPr>
+          <a:xfrm>
+            <a:off x="4484522" y="4324160"/>
+            <a:ext cx="3222650" cy="256032"/>
+          </a:xfrm>
+          <a:prstGeom prst="rect">
+            <a:avLst/>
+          </a:prstGeom>
+          <a:noFill/>
+          <a:ln/>
+        </p:spPr>
+        <p:txBody>
+          <a:bodyPr wrap="square" lIns="0" tIns="0" rIns="0" bIns="0" rtlCol="0" anchor="ctr"/>
+          <a:lstStyle/>
+          <a:p>
+            <a:pPr indent="0" marL="0">
+              <a:buNone/>
+            </a:pPr>
+            <a:r>
+              <a:rPr lang="en-US" sz="1300" b="1" dirty="0">
+                <a:solidFill>
+                  <a:srgbClr val="0D1321"/>
+                </a:solidFill>
+                <a:latin typeface="Helvetica" pitchFamily="34" charset="0"/>
+                <a:ea typeface="Helvetica" pitchFamily="34" charset="-122"/>
+                <a:cs typeface="Helvetica" pitchFamily="34" charset="-120"/>
+              </a:rPr>
+              <a:t>Buat Grafik</a:t>
+            </a:r>
+            <a:endParaRPr lang="en-US" sz="1300" dirty="0"/>
+          </a:p>
+        </p:txBody>
+      </p:sp>
+      <p:sp>
+        <p:nvSpPr>
+          <p:cNvPr id="17" name="Text 15"/>
+          <p:cNvSpPr/>
+          <p:nvPr/>
+        </p:nvSpPr>
+        <p:spPr>
+          <a:xfrm>
+            <a:off x="4484522" y="4635056"/>
+            <a:ext cx="3222650" cy="412115"/>
+          </a:xfrm>
+          <a:prstGeom prst="rect">
+            <a:avLst/>
+          </a:prstGeom>
+          <a:noFill/>
+          <a:ln/>
+        </p:spPr>
+        <p:txBody>
+          <a:bodyPr wrap="square" lIns="0" tIns="0" rIns="0" bIns="0" rtlCol="0" anchor="t"/>
+          <a:lstStyle/>
+          <a:p>
+            <a:pPr indent="0" marL="0">
+              <a:lnSpc>
+                <a:spcPct val="125000"/>
+              </a:lnSpc>
+              <a:buNone/>
+            </a:pPr>
+            <a:r>
+              <a:rPr lang="en-US" sz="1100" dirty="0">
+                <a:solidFill>
+                  <a:srgbClr val="6B7280"/>
+                </a:solidFill>
+                <a:latin typeface="Helvetica" pitchFamily="34" charset="0"/>
+                <a:ea typeface="Helvetica" pitchFamily="34" charset="-122"/>
+                <a:cs typeface="Helvetica" pitchFamily="34" charset="-120"/>
+              </a:rPr>
+              <a:t>Pilih Nama Produk + Total Revenue → Buat Grafik Ringkas.</a:t>
+            </a:r>
+            <a:endParaRPr lang="en-US" sz="1100" dirty="0"/>
+          </a:p>
+        </p:txBody>
+      </p:sp>
+      <p:sp>
+        <p:nvSpPr>
+          <p:cNvPr id="18" name="Shape 16"/>
+          <p:cNvSpPr/>
+          <p:nvPr/>
+        </p:nvSpPr>
+        <p:spPr>
+          <a:xfrm>
+            <a:off x="8091221" y="4159568"/>
+            <a:ext cx="3551834" cy="1052195"/>
+          </a:xfrm>
+          <a:prstGeom prst="roundRect">
+            <a:avLst>
+              <a:gd name="adj" fmla="val 8690"/>
+            </a:avLst>
+          </a:prstGeom>
+          <a:solidFill>
+            <a:srgbClr val="FFFFFF"/>
+          </a:solidFill>
+          <a:ln w="12700">
+            <a:solidFill>
+              <a:srgbClr val="D6DCEB"/>
+            </a:solidFill>
+            <a:prstDash val="solid"/>
+          </a:ln>
+        </p:spPr>
+      </p:sp>
+      <p:sp>
+        <p:nvSpPr>
+          <p:cNvPr id="19" name="Text 17"/>
+          <p:cNvSpPr/>
+          <p:nvPr/>
+        </p:nvSpPr>
+        <p:spPr>
+          <a:xfrm>
+            <a:off x="8255813" y="4324160"/>
+            <a:ext cx="3222650" cy="256032"/>
+          </a:xfrm>
+          <a:prstGeom prst="rect">
+            <a:avLst/>
+          </a:prstGeom>
+          <a:noFill/>
+          <a:ln/>
+        </p:spPr>
+        <p:txBody>
+          <a:bodyPr wrap="square" lIns="0" tIns="0" rIns="0" bIns="0" rtlCol="0" anchor="ctr"/>
+          <a:lstStyle/>
+          <a:p>
+            <a:pPr indent="0" marL="0">
+              <a:buNone/>
+            </a:pPr>
+            <a:r>
+              <a:rPr lang="en-US" sz="1300" b="1" dirty="0">
+                <a:solidFill>
+                  <a:srgbClr val="0D1321"/>
+                </a:solidFill>
+                <a:latin typeface="Helvetica" pitchFamily="34" charset="0"/>
+                <a:ea typeface="Helvetica" pitchFamily="34" charset="-122"/>
+                <a:cs typeface="Helvetica" pitchFamily="34" charset="-120"/>
+              </a:rPr>
+              <a:t>Export PDF</a:t>
+            </a:r>
+            <a:endParaRPr lang="en-US" sz="1300" dirty="0"/>
+          </a:p>
+        </p:txBody>
+      </p:sp>
+      <p:sp>
+        <p:nvSpPr>
+          <p:cNvPr id="20" name="Text 18"/>
+          <p:cNvSpPr/>
+          <p:nvPr/>
+        </p:nvSpPr>
+        <p:spPr>
+          <a:xfrm>
+            <a:off x="8255813" y="4635056"/>
+            <a:ext cx="3222650" cy="412115"/>
+          </a:xfrm>
+          <a:prstGeom prst="rect">
+            <a:avLst/>
+          </a:prstGeom>
+          <a:noFill/>
+          <a:ln/>
+        </p:spPr>
+        <p:txBody>
+          <a:bodyPr wrap="square" lIns="0" tIns="0" rIns="0" bIns="0" rtlCol="0" anchor="t"/>
+          <a:lstStyle/>
+          <a:p>
+            <a:pPr indent="0" marL="0">
+              <a:lnSpc>
+                <a:spcPct val="125000"/>
+              </a:lnSpc>
+              <a:buNone/>
+            </a:pPr>
+            <a:r>
+              <a:rPr lang="en-US" sz="1100" dirty="0">
+                <a:solidFill>
+                  <a:srgbClr val="6B7280"/>
+                </a:solidFill>
+                <a:latin typeface="Helvetica" pitchFamily="34" charset="0"/>
+                <a:ea typeface="Helvetica" pitchFamily="34" charset="-122"/>
+                <a:cs typeface="Helvetica" pitchFamily="34" charset="-120"/>
+              </a:rPr>
+              <a:t>Jalankan Export — judul, angka rapi, dan grafik ikut ter-export.</a:t>
+            </a:r>
+            <a:endParaRPr lang="en-US" sz="1100" dirty="0"/>
+          </a:p>
+        </p:txBody>
+      </p:sp>
+      <p:sp>
+        <p:nvSpPr>
+          <p:cNvPr id="21" name="Shape 19"/>
+          <p:cNvSpPr/>
+          <p:nvPr/>
+        </p:nvSpPr>
+        <p:spPr>
+          <a:xfrm>
+            <a:off x="548640" y="5449507"/>
+            <a:ext cx="11094415" cy="1236853"/>
+          </a:xfrm>
+          <a:prstGeom prst="roundRect">
+            <a:avLst>
+              <a:gd name="adj" fmla="val 7393"/>
             </a:avLst>
           </a:prstGeom>
           <a:solidFill>
@@ -4732,34 +5258,14 @@
       </p:sp>
       <p:sp>
         <p:nvSpPr>
-          <p:cNvPr id="12" name="Shape 10"/>
-          <p:cNvSpPr/>
-          <p:nvPr/>
-        </p:nvSpPr>
-        <p:spPr>
-          <a:xfrm>
-            <a:off x="749808" y="4031552"/>
-            <a:ext cx="384048" cy="384048"/>
-          </a:xfrm>
-          <a:prstGeom prst="ellipse">
-            <a:avLst/>
-          </a:prstGeom>
-          <a:solidFill>
-            <a:srgbClr val="6849F6"/>
-          </a:solidFill>
-          <a:ln/>
-        </p:spPr>
-      </p:sp>
-      <p:sp>
-        <p:nvSpPr>
-          <p:cNvPr id="13" name="Text 11"/>
-          <p:cNvSpPr/>
-          <p:nvPr/>
-        </p:nvSpPr>
-        <p:spPr>
-          <a:xfrm>
-            <a:off x="749808" y="4031552"/>
-            <a:ext cx="384048" cy="384048"/>
+          <p:cNvPr id="22" name="Text 20"/>
+          <p:cNvSpPr/>
+          <p:nvPr/>
+        </p:nvSpPr>
+        <p:spPr>
+          <a:xfrm>
+            <a:off x="749808" y="5650675"/>
+            <a:ext cx="10692079" cy="274320"/>
           </a:xfrm>
           <a:prstGeom prst="rect">
             <a:avLst/>
@@ -4771,318 +5277,23 @@
           <a:bodyPr wrap="square" lIns="0" tIns="0" rIns="0" bIns="0" rtlCol="0" anchor="ctr"/>
           <a:lstStyle/>
           <a:p>
-            <a:pPr algn="ctr" indent="0" marL="0">
-              <a:buNone/>
-            </a:pPr>
-            <a:r>
-              <a:rPr lang="en-US" sz="1400" b="1" dirty="0">
-                <a:solidFill>
-                  <a:srgbClr val="FFFFFF"/>
-                </a:solidFill>
-                <a:latin typeface="Helvetica" pitchFamily="34" charset="0"/>
-                <a:ea typeface="Helvetica" pitchFamily="34" charset="-122"/>
-                <a:cs typeface="Helvetica" pitchFamily="34" charset="-120"/>
-              </a:rPr>
-              <a:t>1</a:t>
-            </a:r>
-            <a:endParaRPr lang="en-US" sz="1400" dirty="0"/>
-          </a:p>
-        </p:txBody>
-      </p:sp>
-      <p:sp>
-        <p:nvSpPr>
-          <p:cNvPr id="14" name="Text 12"/>
-          <p:cNvSpPr/>
-          <p:nvPr/>
-        </p:nvSpPr>
-        <p:spPr>
-          <a:xfrm>
-            <a:off x="1271016" y="4013264"/>
-            <a:ext cx="2603906" cy="310896"/>
-          </a:xfrm>
-          <a:prstGeom prst="rect">
-            <a:avLst/>
-          </a:prstGeom>
-          <a:noFill/>
-          <a:ln/>
-        </p:spPr>
-        <p:txBody>
-          <a:bodyPr wrap="square" lIns="0" tIns="0" rIns="0" bIns="0" rtlCol="0" anchor="ctr"/>
-          <a:lstStyle/>
-          <a:p>
-            <a:pPr indent="0" marL="0">
-              <a:buNone/>
-            </a:pPr>
-            <a:r>
-              <a:rPr lang="en-US" sz="1400" b="1" dirty="0">
-                <a:solidFill>
-                  <a:srgbClr val="0D1321"/>
-                </a:solidFill>
-                <a:latin typeface="Helvetica" pitchFamily="34" charset="0"/>
-                <a:ea typeface="Helvetica" pitchFamily="34" charset="-122"/>
-                <a:cs typeface="Helvetica" pitchFamily="34" charset="-120"/>
-              </a:rPr>
-              <a:t>Rapikan &amp; Beri Judul</a:t>
-            </a:r>
-            <a:endParaRPr lang="en-US" sz="1400" dirty="0"/>
-          </a:p>
-        </p:txBody>
-      </p:sp>
-      <p:sp>
-        <p:nvSpPr>
-          <p:cNvPr id="15" name="Text 13"/>
-          <p:cNvSpPr/>
-          <p:nvPr/>
-        </p:nvSpPr>
-        <p:spPr>
-          <a:xfrm>
-            <a:off x="749808" y="4452176"/>
-            <a:ext cx="3125114" cy="438790"/>
-          </a:xfrm>
-          <a:prstGeom prst="rect">
-            <a:avLst/>
-          </a:prstGeom>
-          <a:noFill/>
-          <a:ln/>
-        </p:spPr>
-        <p:txBody>
-          <a:bodyPr wrap="square" lIns="0" tIns="0" rIns="0" bIns="0" rtlCol="0" anchor="t"/>
-          <a:lstStyle/>
-          <a:p>
-            <a:pPr indent="0" marL="0">
-              <a:lnSpc>
-                <a:spcPct val="122000"/>
-              </a:lnSpc>
-              <a:buNone/>
-            </a:pPr>
-            <a:r>
-              <a:rPr lang="en-US" sz="1200" dirty="0">
-                <a:solidFill>
-                  <a:srgbClr val="23283A"/>
-                </a:solidFill>
-                <a:latin typeface="Helvetica" pitchFamily="34" charset="0"/>
-                <a:ea typeface="Helvetica" pitchFamily="34" charset="-122"/>
-                <a:cs typeface="Helvetica" pitchFamily="34" charset="-120"/>
-              </a:rPr>
-              <a:t>Pilih kolom hasil SUMIF → format Rupiah. Pilih data → tambah judul laporan.</a:t>
-            </a:r>
-            <a:endParaRPr lang="en-US" sz="1200" dirty="0"/>
-          </a:p>
-        </p:txBody>
-      </p:sp>
-      <p:sp>
-        <p:nvSpPr>
-          <p:cNvPr id="16" name="Shape 14"/>
-          <p:cNvSpPr/>
-          <p:nvPr/>
-        </p:nvSpPr>
-        <p:spPr>
-          <a:xfrm>
-            <a:off x="4332122" y="3830384"/>
-            <a:ext cx="3527450" cy="1261750"/>
-          </a:xfrm>
-          <a:prstGeom prst="roundRect">
-            <a:avLst>
-              <a:gd name="adj" fmla="val 7247"/>
-            </a:avLst>
-          </a:prstGeom>
-          <a:solidFill>
-            <a:srgbClr val="F3F0FF"/>
-          </a:solidFill>
-          <a:ln w="12700">
-            <a:solidFill>
-              <a:srgbClr val="DCD3FB"/>
-            </a:solidFill>
-            <a:prstDash val="solid"/>
-          </a:ln>
-        </p:spPr>
-      </p:sp>
-      <p:sp>
-        <p:nvSpPr>
-          <p:cNvPr id="17" name="Shape 15"/>
-          <p:cNvSpPr/>
-          <p:nvPr/>
-        </p:nvSpPr>
-        <p:spPr>
-          <a:xfrm>
-            <a:off x="4533290" y="4031552"/>
-            <a:ext cx="384048" cy="384048"/>
-          </a:xfrm>
-          <a:prstGeom prst="ellipse">
-            <a:avLst/>
-          </a:prstGeom>
-          <a:solidFill>
-            <a:srgbClr val="6849F6"/>
-          </a:solidFill>
-          <a:ln/>
-        </p:spPr>
-      </p:sp>
-      <p:sp>
-        <p:nvSpPr>
-          <p:cNvPr id="18" name="Text 16"/>
-          <p:cNvSpPr/>
-          <p:nvPr/>
-        </p:nvSpPr>
-        <p:spPr>
-          <a:xfrm>
-            <a:off x="4533290" y="4031552"/>
-            <a:ext cx="384048" cy="384048"/>
-          </a:xfrm>
-          <a:prstGeom prst="rect">
-            <a:avLst/>
-          </a:prstGeom>
-          <a:noFill/>
-          <a:ln/>
-        </p:spPr>
-        <p:txBody>
-          <a:bodyPr wrap="square" lIns="0" tIns="0" rIns="0" bIns="0" rtlCol="0" anchor="ctr"/>
-          <a:lstStyle/>
-          <a:p>
-            <a:pPr algn="ctr" indent="0" marL="0">
-              <a:buNone/>
-            </a:pPr>
-            <a:r>
-              <a:rPr lang="en-US" sz="1400" b="1" dirty="0">
-                <a:solidFill>
-                  <a:srgbClr val="FFFFFF"/>
-                </a:solidFill>
-                <a:latin typeface="Helvetica" pitchFamily="34" charset="0"/>
-                <a:ea typeface="Helvetica" pitchFamily="34" charset="-122"/>
-                <a:cs typeface="Helvetica" pitchFamily="34" charset="-120"/>
-              </a:rPr>
-              <a:t>2</a:t>
-            </a:r>
-            <a:endParaRPr lang="en-US" sz="1400" dirty="0"/>
-          </a:p>
-        </p:txBody>
-      </p:sp>
-      <p:sp>
-        <p:nvSpPr>
-          <p:cNvPr id="19" name="Text 17"/>
-          <p:cNvSpPr/>
-          <p:nvPr/>
-        </p:nvSpPr>
-        <p:spPr>
-          <a:xfrm>
-            <a:off x="5054498" y="4013264"/>
-            <a:ext cx="2603906" cy="310896"/>
-          </a:xfrm>
-          <a:prstGeom prst="rect">
-            <a:avLst/>
-          </a:prstGeom>
-          <a:noFill/>
-          <a:ln/>
-        </p:spPr>
-        <p:txBody>
-          <a:bodyPr wrap="square" lIns="0" tIns="0" rIns="0" bIns="0" rtlCol="0" anchor="ctr"/>
-          <a:lstStyle/>
-          <a:p>
-            <a:pPr indent="0" marL="0">
-              <a:buNone/>
-            </a:pPr>
-            <a:r>
-              <a:rPr lang="en-US" sz="1400" b="1" dirty="0">
-                <a:solidFill>
-                  <a:srgbClr val="0D1321"/>
-                </a:solidFill>
-                <a:latin typeface="Helvetica" pitchFamily="34" charset="0"/>
-                <a:ea typeface="Helvetica" pitchFamily="34" charset="-122"/>
-                <a:cs typeface="Helvetica" pitchFamily="34" charset="-120"/>
-              </a:rPr>
-              <a:t>Buat Grafik</a:t>
-            </a:r>
-            <a:endParaRPr lang="en-US" sz="1400" dirty="0"/>
-          </a:p>
-        </p:txBody>
-      </p:sp>
-      <p:sp>
-        <p:nvSpPr>
-          <p:cNvPr id="20" name="Text 18"/>
-          <p:cNvSpPr/>
-          <p:nvPr/>
-        </p:nvSpPr>
-        <p:spPr>
-          <a:xfrm>
-            <a:off x="4533290" y="4452176"/>
-            <a:ext cx="3125114" cy="438790"/>
-          </a:xfrm>
-          <a:prstGeom prst="rect">
-            <a:avLst/>
-          </a:prstGeom>
-          <a:noFill/>
-          <a:ln/>
-        </p:spPr>
-        <p:txBody>
-          <a:bodyPr wrap="square" lIns="0" tIns="0" rIns="0" bIns="0" rtlCol="0" anchor="t"/>
-          <a:lstStyle/>
-          <a:p>
-            <a:pPr indent="0" marL="0">
-              <a:lnSpc>
-                <a:spcPct val="122000"/>
-              </a:lnSpc>
-              <a:buNone/>
-            </a:pPr>
-            <a:r>
-              <a:rPr lang="en-US" sz="1200" dirty="0">
-                <a:solidFill>
-                  <a:srgbClr val="23283A"/>
-                </a:solidFill>
-                <a:latin typeface="Helvetica" pitchFamily="34" charset="0"/>
-                <a:ea typeface="Helvetica" pitchFamily="34" charset="-122"/>
-                <a:cs typeface="Helvetica" pitchFamily="34" charset="-120"/>
-              </a:rPr>
-              <a:t>Pilih Nama Produk + Total Revenue → Buat Grafik Ringkas.</a:t>
-            </a:r>
-            <a:endParaRPr lang="en-US" sz="1200" dirty="0"/>
-          </a:p>
-        </p:txBody>
-      </p:sp>
-      <p:sp>
-        <p:nvSpPr>
-          <p:cNvPr id="21" name="Shape 19"/>
-          <p:cNvSpPr/>
-          <p:nvPr/>
-        </p:nvSpPr>
-        <p:spPr>
-          <a:xfrm>
-            <a:off x="8115605" y="3830384"/>
-            <a:ext cx="3527450" cy="1261750"/>
-          </a:xfrm>
-          <a:prstGeom prst="roundRect">
-            <a:avLst>
-              <a:gd name="adj" fmla="val 7247"/>
-            </a:avLst>
-          </a:prstGeom>
-          <a:solidFill>
-            <a:srgbClr val="F3F0FF"/>
-          </a:solidFill>
-          <a:ln w="12700">
-            <a:solidFill>
-              <a:srgbClr val="DCD3FB"/>
-            </a:solidFill>
-            <a:prstDash val="solid"/>
-          </a:ln>
-        </p:spPr>
-      </p:sp>
-      <p:sp>
-        <p:nvSpPr>
-          <p:cNvPr id="22" name="Shape 20"/>
-          <p:cNvSpPr/>
-          <p:nvPr/>
-        </p:nvSpPr>
-        <p:spPr>
-          <a:xfrm>
-            <a:off x="8316773" y="4031552"/>
-            <a:ext cx="384048" cy="384048"/>
-          </a:xfrm>
-          <a:prstGeom prst="ellipse">
-            <a:avLst/>
-          </a:prstGeom>
-          <a:solidFill>
-            <a:srgbClr val="6849F6"/>
-          </a:solidFill>
-          <a:ln/>
-        </p:spPr>
+            <a:pPr indent="0" marL="0">
+              <a:buNone/>
+            </a:pPr>
+            <a:r>
+              <a:rPr lang="en-US" sz="1250" b="1" spc="30" kern="0" dirty="0">
+                <a:solidFill>
+                  <a:srgbClr val="4B36C7"/>
+                </a:solidFill>
+                <a:latin typeface="Helvetica" pitchFamily="34" charset="0"/>
+                <a:ea typeface="Helvetica" pitchFamily="34" charset="-122"/>
+                <a:cs typeface="Helvetica" pitchFamily="34" charset="-120"/>
+              </a:rPr>
+              <a:t>◆  TIP — CLAUDE IN CHROME: SPREADSHEET TANPA COPY-PASTE</a:t>
+            </a:r>
+            <a:endParaRPr lang="en-US" sz="1250" dirty="0"/>
+          </a:p>
+        </p:txBody>
       </p:sp>
       <p:sp>
         <p:nvSpPr>
@@ -5092,543 +5303,7 @@
         </p:nvSpPr>
         <p:spPr>
           <a:xfrm>
-            <a:off x="8316773" y="4031552"/>
-            <a:ext cx="384048" cy="384048"/>
-          </a:xfrm>
-          <a:prstGeom prst="rect">
-            <a:avLst/>
-          </a:prstGeom>
-          <a:noFill/>
-          <a:ln/>
-        </p:spPr>
-        <p:txBody>
-          <a:bodyPr wrap="square" lIns="0" tIns="0" rIns="0" bIns="0" rtlCol="0" anchor="ctr"/>
-          <a:lstStyle/>
-          <a:p>
-            <a:pPr algn="ctr" indent="0" marL="0">
-              <a:buNone/>
-            </a:pPr>
-            <a:r>
-              <a:rPr lang="en-US" sz="1400" b="1" dirty="0">
-                <a:solidFill>
-                  <a:srgbClr val="FFFFFF"/>
-                </a:solidFill>
-                <a:latin typeface="Helvetica" pitchFamily="34" charset="0"/>
-                <a:ea typeface="Helvetica" pitchFamily="34" charset="-122"/>
-                <a:cs typeface="Helvetica" pitchFamily="34" charset="-120"/>
-              </a:rPr>
-              <a:t>3</a:t>
-            </a:r>
-            <a:endParaRPr lang="en-US" sz="1400" dirty="0"/>
-          </a:p>
-        </p:txBody>
-      </p:sp>
-      <p:sp>
-        <p:nvSpPr>
-          <p:cNvPr id="24" name="Text 22"/>
-          <p:cNvSpPr/>
-          <p:nvPr/>
-        </p:nvSpPr>
-        <p:spPr>
-          <a:xfrm>
-            <a:off x="8837981" y="4013264"/>
-            <a:ext cx="2603906" cy="310896"/>
-          </a:xfrm>
-          <a:prstGeom prst="rect">
-            <a:avLst/>
-          </a:prstGeom>
-          <a:noFill/>
-          <a:ln/>
-        </p:spPr>
-        <p:txBody>
-          <a:bodyPr wrap="square" lIns="0" tIns="0" rIns="0" bIns="0" rtlCol="0" anchor="ctr"/>
-          <a:lstStyle/>
-          <a:p>
-            <a:pPr indent="0" marL="0">
-              <a:buNone/>
-            </a:pPr>
-            <a:r>
-              <a:rPr lang="en-US" sz="1400" b="1" dirty="0">
-                <a:solidFill>
-                  <a:srgbClr val="0D1321"/>
-                </a:solidFill>
-                <a:latin typeface="Helvetica" pitchFamily="34" charset="0"/>
-                <a:ea typeface="Helvetica" pitchFamily="34" charset="-122"/>
-                <a:cs typeface="Helvetica" pitchFamily="34" charset="-120"/>
-              </a:rPr>
-              <a:t>Export PDF</a:t>
-            </a:r>
-            <a:endParaRPr lang="en-US" sz="1400" dirty="0"/>
-          </a:p>
-        </p:txBody>
-      </p:sp>
-      <p:sp>
-        <p:nvSpPr>
-          <p:cNvPr id="25" name="Text 23"/>
-          <p:cNvSpPr/>
-          <p:nvPr/>
-        </p:nvSpPr>
-        <p:spPr>
-          <a:xfrm>
-            <a:off x="8316773" y="4452176"/>
-            <a:ext cx="3125114" cy="438790"/>
-          </a:xfrm>
-          <a:prstGeom prst="rect">
-            <a:avLst/>
-          </a:prstGeom>
-          <a:noFill/>
-          <a:ln/>
-        </p:spPr>
-        <p:txBody>
-          <a:bodyPr wrap="square" lIns="0" tIns="0" rIns="0" bIns="0" rtlCol="0" anchor="t"/>
-          <a:lstStyle/>
-          <a:p>
-            <a:pPr indent="0" marL="0">
-              <a:lnSpc>
-                <a:spcPct val="122000"/>
-              </a:lnSpc>
-              <a:buNone/>
-            </a:pPr>
-            <a:r>
-              <a:rPr lang="en-US" sz="1200" dirty="0">
-                <a:solidFill>
-                  <a:srgbClr val="23283A"/>
-                </a:solidFill>
-                <a:latin typeface="Helvetica" pitchFamily="34" charset="0"/>
-                <a:ea typeface="Helvetica" pitchFamily="34" charset="-122"/>
-                <a:cs typeface="Helvetica" pitchFamily="34" charset="-120"/>
-              </a:rPr>
-              <a:t>Jalankan Export — judul, angka rapi, dan grafik ikut ter-export.</a:t>
-            </a:r>
-            <a:endParaRPr lang="en-US" sz="1200" dirty="0"/>
-          </a:p>
-        </p:txBody>
-      </p:sp>
-    </p:spTree>
-  </p:cSld>
-  <p:clrMapOvr>
-    <a:masterClrMapping/>
-  </p:clrMapOvr>
-</p:sld>
-</file>
-
-<file path=ppt/slides/slide7.xml><?xml version="1.0" encoding="utf-8"?>
-<p:sld xmlns:a="http://schemas.openxmlformats.org/drawingml/2006/main" xmlns:r="http://schemas.openxmlformats.org/officeDocument/2006/relationships" xmlns:p="http://schemas.openxmlformats.org/presentationml/2006/main">
-  <p:cSld name="Slide 7">
-    <p:bg>
-      <p:bgPr>
-        <a:solidFill>
-          <a:srgbClr val="FFFFFF"/>
-        </a:solidFill>
-      </p:bgPr>
-    </p:bg>
-    <p:spTree>
-      <p:nvGrpSpPr>
-        <p:cNvPr id="1" name=""/>
-        <p:cNvGrpSpPr/>
-        <p:nvPr/>
-      </p:nvGrpSpPr>
-      <p:grpSpPr>
-        <a:xfrm>
-          <a:off x="0" y="0"/>
-          <a:ext cx="0" cy="0"/>
-          <a:chOff x="0" y="0"/>
-          <a:chExt cx="0" cy="0"/>
-        </a:xfrm>
-      </p:grpSpPr>
-      <p:sp>
-        <p:nvSpPr>
-          <p:cNvPr id="2" name="Shape 0"/>
-          <p:cNvSpPr/>
-          <p:nvPr/>
-        </p:nvSpPr>
-        <p:spPr>
-          <a:xfrm>
-            <a:off x="0" y="0"/>
-            <a:ext cx="12191695" cy="960120"/>
-          </a:xfrm>
-          <a:prstGeom prst="rect">
-            <a:avLst/>
-          </a:prstGeom>
-          <a:solidFill>
-            <a:srgbClr val="0D1321"/>
-          </a:solidFill>
-          <a:ln/>
-        </p:spPr>
-      </p:sp>
-      <p:sp>
-        <p:nvSpPr>
-          <p:cNvPr id="3" name="Shape 1"/>
-          <p:cNvSpPr/>
-          <p:nvPr/>
-        </p:nvSpPr>
-        <p:spPr>
-          <a:xfrm>
-            <a:off x="0" y="960120"/>
-            <a:ext cx="12191695" cy="41148"/>
-          </a:xfrm>
-          <a:prstGeom prst="rect">
-            <a:avLst/>
-          </a:prstGeom>
-          <a:solidFill>
-            <a:srgbClr val="6849F6"/>
-          </a:solidFill>
-          <a:ln/>
-        </p:spPr>
-      </p:sp>
-      <p:sp>
-        <p:nvSpPr>
-          <p:cNvPr id="4" name="Text 2"/>
-          <p:cNvSpPr/>
-          <p:nvPr/>
-        </p:nvSpPr>
-        <p:spPr>
-          <a:xfrm>
-            <a:off x="502920" y="256032"/>
-            <a:ext cx="3657600" cy="457200"/>
-          </a:xfrm>
-          <a:prstGeom prst="rect">
-            <a:avLst/>
-          </a:prstGeom>
-          <a:noFill/>
-          <a:ln/>
-        </p:spPr>
-        <p:txBody>
-          <a:bodyPr wrap="square" lIns="0" tIns="0" rIns="0" bIns="0" rtlCol="0" anchor="ctr"/>
-          <a:lstStyle/>
-          <a:p>
-            <a:pPr indent="0" marL="0">
-              <a:buNone/>
-            </a:pPr>
-            <a:r>
-              <a:rPr lang="en-US" sz="2000" b="1" dirty="0">
-                <a:solidFill>
-                  <a:srgbClr val="FFFFFF"/>
-                </a:solidFill>
-                <a:latin typeface="Helvetica" pitchFamily="34" charset="0"/>
-                <a:ea typeface="Helvetica" pitchFamily="34" charset="-122"/>
-                <a:cs typeface="Helvetica" pitchFamily="34" charset="-120"/>
-              </a:rPr>
-              <a:t>belajar</a:t>
-            </a:r>
-            <a:pPr indent="0" marL="0">
-              <a:buNone/>
-            </a:pPr>
-            <a:r>
-              <a:rPr lang="en-US" sz="2000" b="1" dirty="0">
-                <a:solidFill>
-                  <a:srgbClr val="8B7CF6"/>
-                </a:solidFill>
-                <a:latin typeface="Helvetica" pitchFamily="34" charset="0"/>
-                <a:ea typeface="Helvetica" pitchFamily="34" charset="-122"/>
-                <a:cs typeface="Helvetica" pitchFamily="34" charset="-120"/>
-              </a:rPr>
-              <a:t>claude</a:t>
-            </a:r>
-            <a:endParaRPr lang="en-US" sz="2000" dirty="0"/>
-          </a:p>
-        </p:txBody>
-      </p:sp>
-      <p:sp>
-        <p:nvSpPr>
-          <p:cNvPr id="5" name="Text 3"/>
-          <p:cNvSpPr/>
-          <p:nvPr/>
-        </p:nvSpPr>
-        <p:spPr>
-          <a:xfrm>
-            <a:off x="5943600" y="274320"/>
-            <a:ext cx="5760720" cy="411480"/>
-          </a:xfrm>
-          <a:prstGeom prst="rect">
-            <a:avLst/>
-          </a:prstGeom>
-          <a:noFill/>
-          <a:ln/>
-        </p:spPr>
-        <p:txBody>
-          <a:bodyPr wrap="square" lIns="0" tIns="0" rIns="0" bIns="0" rtlCol="0" anchor="ctr"/>
-          <a:lstStyle/>
-          <a:p>
-            <a:pPr algn="r" indent="0" marL="0">
-              <a:buNone/>
-            </a:pPr>
-            <a:r>
-              <a:rPr lang="en-US" sz="1250" dirty="0">
-                <a:solidFill>
-                  <a:srgbClr val="9AA2B4"/>
-                </a:solidFill>
-                <a:latin typeface="Helvetica" pitchFamily="34" charset="0"/>
-                <a:ea typeface="Helvetica" pitchFamily="34" charset="-122"/>
-                <a:cs typeface="Helvetica" pitchFamily="34" charset="-120"/>
-              </a:rPr>
-              <a:t>Modul 04 — Spreadsheet &amp; Claude</a:t>
-            </a:r>
-            <a:endParaRPr lang="en-US" sz="1250" dirty="0"/>
-          </a:p>
-        </p:txBody>
-      </p:sp>
-      <p:sp>
-        <p:nvSpPr>
-          <p:cNvPr id="6" name="Text 4"/>
-          <p:cNvSpPr/>
-          <p:nvPr/>
-        </p:nvSpPr>
-        <p:spPr>
-          <a:xfrm>
-            <a:off x="548640" y="1188720"/>
-            <a:ext cx="11064240" cy="502920"/>
-          </a:xfrm>
-          <a:prstGeom prst="rect">
-            <a:avLst/>
-          </a:prstGeom>
-          <a:noFill/>
-          <a:ln/>
-        </p:spPr>
-        <p:txBody>
-          <a:bodyPr wrap="square" lIns="0" tIns="0" rIns="0" bIns="0" rtlCol="0" anchor="ctr"/>
-          <a:lstStyle/>
-          <a:p>
-            <a:pPr indent="0" marL="0">
-              <a:buNone/>
-            </a:pPr>
-            <a:r>
-              <a:rPr lang="en-US" sz="2200" b="1" dirty="0">
-                <a:solidFill>
-                  <a:srgbClr val="0D1321"/>
-                </a:solidFill>
-                <a:latin typeface="Helvetica" pitchFamily="34" charset="0"/>
-                <a:ea typeface="Helvetica" pitchFamily="34" charset="-122"/>
-                <a:cs typeface="Helvetica" pitchFamily="34" charset="-120"/>
-              </a:rPr>
-              <a:t>Level Up: Dashboard Performa Produk</a:t>
-            </a:r>
-            <a:endParaRPr lang="en-US" sz="2200" dirty="0"/>
-          </a:p>
-        </p:txBody>
-      </p:sp>
-      <p:sp>
-        <p:nvSpPr>
-          <p:cNvPr id="7" name="Text 5"/>
-          <p:cNvSpPr/>
-          <p:nvPr/>
-        </p:nvSpPr>
-        <p:spPr>
-          <a:xfrm>
-            <a:off x="548640" y="1783080"/>
-            <a:ext cx="11094415" cy="274320"/>
-          </a:xfrm>
-          <a:prstGeom prst="rect">
-            <a:avLst/>
-          </a:prstGeom>
-          <a:noFill/>
-          <a:ln/>
-        </p:spPr>
-        <p:txBody>
-          <a:bodyPr wrap="square" lIns="0" tIns="0" rIns="0" bIns="0" rtlCol="0" anchor="ctr"/>
-          <a:lstStyle/>
-          <a:p>
-            <a:pPr indent="0" marL="0">
-              <a:buNone/>
-            </a:pPr>
-            <a:r>
-              <a:rPr lang="en-US" sz="1250" b="1" spc="40" kern="0" dirty="0">
-                <a:solidFill>
-                  <a:srgbClr val="4B36C7"/>
-                </a:solidFill>
-                <a:latin typeface="Helvetica" pitchFamily="34" charset="0"/>
-                <a:ea typeface="Helvetica" pitchFamily="34" charset="-122"/>
-                <a:cs typeface="Helvetica" pitchFamily="34" charset="-120"/>
-              </a:rPr>
-              <a:t>BONUS — SATU HALAMAN, BUKAN CUMA FORMULA</a:t>
-            </a:r>
-            <a:endParaRPr lang="en-US" sz="1250" dirty="0"/>
-          </a:p>
-        </p:txBody>
-      </p:sp>
-      <p:sp>
-        <p:nvSpPr>
-          <p:cNvPr id="8" name="Shape 6"/>
-          <p:cNvSpPr/>
-          <p:nvPr/>
-        </p:nvSpPr>
-        <p:spPr>
-          <a:xfrm>
-            <a:off x="548640" y="2112264"/>
-            <a:ext cx="11094415" cy="1429283"/>
-          </a:xfrm>
-          <a:prstGeom prst="roundRect">
-            <a:avLst>
-              <a:gd name="adj" fmla="val 6398"/>
-            </a:avLst>
-          </a:prstGeom>
-          <a:solidFill>
-            <a:srgbClr val="141D33"/>
-          </a:solidFill>
-          <a:ln w="12700">
-            <a:solidFill>
-              <a:srgbClr val="6849F6"/>
-            </a:solidFill>
-            <a:prstDash val="solid"/>
-          </a:ln>
-        </p:spPr>
-      </p:sp>
-      <p:sp>
-        <p:nvSpPr>
-          <p:cNvPr id="9" name="Text 7"/>
-          <p:cNvSpPr/>
-          <p:nvPr/>
-        </p:nvSpPr>
-        <p:spPr>
-          <a:xfrm>
-            <a:off x="768096" y="2331720"/>
-            <a:ext cx="10655503" cy="256032"/>
-          </a:xfrm>
-          <a:prstGeom prst="rect">
-            <a:avLst/>
-          </a:prstGeom>
-          <a:noFill/>
-          <a:ln/>
-        </p:spPr>
-        <p:txBody>
-          <a:bodyPr wrap="square" lIns="0" tIns="0" rIns="0" bIns="0" rtlCol="0" anchor="ctr"/>
-          <a:lstStyle/>
-          <a:p>
-            <a:pPr indent="0" marL="0">
-              <a:buNone/>
-            </a:pPr>
-            <a:r>
-              <a:rPr lang="en-US" sz="1150" b="1" spc="30" kern="0" dirty="0">
-                <a:solidFill>
-                  <a:srgbClr val="8B7CF6"/>
-                </a:solidFill>
-                <a:latin typeface="Helvetica" pitchFamily="34" charset="0"/>
-                <a:ea typeface="Helvetica" pitchFamily="34" charset="-122"/>
-                <a:cs typeface="Helvetica" pitchFamily="34" charset="-120"/>
-              </a:rPr>
-              <a:t>CONTOH PROMPT</a:t>
-            </a:r>
-            <a:endParaRPr lang="en-US" sz="1150" dirty="0"/>
-          </a:p>
-        </p:txBody>
-      </p:sp>
-      <p:sp>
-        <p:nvSpPr>
-          <p:cNvPr id="10" name="Text 8"/>
-          <p:cNvSpPr/>
-          <p:nvPr/>
-        </p:nvSpPr>
-        <p:spPr>
-          <a:xfrm>
-            <a:off x="768096" y="2679192"/>
-            <a:ext cx="10655503" cy="642899"/>
-          </a:xfrm>
-          <a:prstGeom prst="rect">
-            <a:avLst/>
-          </a:prstGeom>
-          <a:noFill/>
-          <a:ln/>
-        </p:spPr>
-        <p:txBody>
-          <a:bodyPr wrap="square" lIns="0" tIns="0" rIns="0" bIns="0" rtlCol="0" anchor="t"/>
-          <a:lstStyle/>
-          <a:p>
-            <a:pPr indent="0" marL="0">
-              <a:lnSpc>
-                <a:spcPct val="130000"/>
-              </a:lnSpc>
-              <a:buNone/>
-            </a:pPr>
-            <a:r>
-              <a:rPr lang="en-US" sz="1100" dirty="0">
-                <a:solidFill>
-                  <a:srgbClr val="C7CDE0"/>
-                </a:solidFill>
-                <a:latin typeface="Helvetica" pitchFamily="34" charset="0"/>
-                <a:ea typeface="Helvetica" pitchFamily="34" charset="-122"/>
-                <a:cs typeface="Helvetica" pitchFamily="34" charset="-120"/>
-              </a:rPr>
-              <a:t>[Upload atau paste k2-data-latihan-sheets.csv] Dari data transaksi ini, buatkan saya dashboard HTML sederhana: tabel semua produk dengan kolom total qty terjual dan total revenue (SUMIF per Produk). Beri warna hijau kalau revenue di atas rata-rata semua produk, kuning kalau mendekati rata-rata, merah kalau jauh di bawah rata-rata. Simpan sebagai 1 file HTML yang bisa saya buka tiap minggu.</a:t>
-            </a:r>
-            <a:endParaRPr lang="en-US" sz="1100" dirty="0"/>
-          </a:p>
-        </p:txBody>
-      </p:sp>
-      <p:sp>
-        <p:nvSpPr>
-          <p:cNvPr id="11" name="Shape 9"/>
-          <p:cNvSpPr/>
-          <p:nvPr/>
-        </p:nvSpPr>
-        <p:spPr>
-          <a:xfrm>
-            <a:off x="548640" y="3779291"/>
-            <a:ext cx="11094415" cy="1236853"/>
-          </a:xfrm>
-          <a:prstGeom prst="roundRect">
-            <a:avLst>
-              <a:gd name="adj" fmla="val 7393"/>
-            </a:avLst>
-          </a:prstGeom>
-          <a:solidFill>
-            <a:srgbClr val="F3F0FF"/>
-          </a:solidFill>
-          <a:ln w="12700">
-            <a:solidFill>
-              <a:srgbClr val="DCD3FB"/>
-            </a:solidFill>
-            <a:prstDash val="solid"/>
-          </a:ln>
-        </p:spPr>
-      </p:sp>
-      <p:sp>
-        <p:nvSpPr>
-          <p:cNvPr id="12" name="Text 10"/>
-          <p:cNvSpPr/>
-          <p:nvPr/>
-        </p:nvSpPr>
-        <p:spPr>
-          <a:xfrm>
-            <a:off x="749808" y="3980459"/>
-            <a:ext cx="10692079" cy="274320"/>
-          </a:xfrm>
-          <a:prstGeom prst="rect">
-            <a:avLst/>
-          </a:prstGeom>
-          <a:noFill/>
-          <a:ln/>
-        </p:spPr>
-        <p:txBody>
-          <a:bodyPr wrap="square" lIns="0" tIns="0" rIns="0" bIns="0" rtlCol="0" anchor="ctr"/>
-          <a:lstStyle/>
-          <a:p>
-            <a:pPr indent="0" marL="0">
-              <a:buNone/>
-            </a:pPr>
-            <a:r>
-              <a:rPr lang="en-US" sz="1250" b="1" spc="30" kern="0" dirty="0">
-                <a:solidFill>
-                  <a:srgbClr val="4B36C7"/>
-                </a:solidFill>
-                <a:latin typeface="Helvetica" pitchFamily="34" charset="0"/>
-                <a:ea typeface="Helvetica" pitchFamily="34" charset="-122"/>
-                <a:cs typeface="Helvetica" pitchFamily="34" charset="-120"/>
-              </a:rPr>
-              <a:t>◆  TIP — CLAUDE IN CHROME: SPREADSHEET TANPA COPY-PASTE</a:t>
-            </a:r>
-            <a:endParaRPr lang="en-US" sz="1250" dirty="0"/>
-          </a:p>
-        </p:txBody>
-      </p:sp>
-      <p:sp>
-        <p:nvSpPr>
-          <p:cNvPr id="13" name="Text 11"/>
-          <p:cNvSpPr/>
-          <p:nvPr/>
-        </p:nvSpPr>
-        <p:spPr>
-          <a:xfrm>
-            <a:off x="749808" y="4327931"/>
+            <a:off x="749808" y="5998147"/>
             <a:ext cx="10692079" cy="487045"/>
           </a:xfrm>
           <a:prstGeom prst="rect">

</xml_diff>

<commit_message>
K2 M4: remove '(bukan langkah berurutan)' from Apps Script menu label, add Claude for Excel (Excel Desktop add-in) info alongside Claude in Chrome tip, fix stray backslash typo in HTML tip text
</commit_message>
<xml_diff>
--- a/K2-Produktivitas/M04-Google-Sheets/K2-M04-Google-Sheets.pptx
+++ b/K2-Produktivitas/M04-Google-Sheets/K2-M04-Google-Sheets.pptx
@@ -11,9 +11,10 @@
     <p:sldId id="259" r:id="rId5"/>
     <p:sldId id="260" r:id="rId6"/>
     <p:sldId id="261" r:id="rId7"/>
+    <p:sldId id="262" r:id="rId8"/>
   </p:sldIdLst>
   <p:notesMasterIdLst>
-    <p:notesMasterId r:id="rId8"/>
+    <p:notesMasterId r:id="rId9"/>
   </p:notesMasterIdLst>
   <p:sldSz cx="12191695" cy="6858000"/>
   <p:notesSz cx="6858000" cy="12191695"/>
@@ -971,6 +972,94 @@
             <a:fld id="{F7021451-1387-4CA6-816F-3879F97B5CBC}" type="slidenum">
               <a:rPr lang="en-US"/>
               <a:t>6</a:t>
+            </a:fld>
+            <a:endParaRPr lang="en-US"/>
+          </a:p>
+        </p:txBody>
+      </p:sp>
+    </p:spTree>
+    <p:extLst>
+      <p:ext uri="{BB962C8B-B14F-4D97-AF65-F5344CB8AC3E}">
+        <p14:creationId xmlns:p14="http://schemas.microsoft.com/office/powerpoint/2010/main" val="1024086991"/>
+      </p:ext>
+    </p:extLst>
+  </p:cSld>
+  <p:clrMapOvr>
+    <a:masterClrMapping/>
+  </p:clrMapOvr>
+</p:notes>
+</file>
+
+<file path=ppt/notesSlides/notesSlide7.xml><?xml version="1.0" encoding="utf-8"?>
+<p:notes xmlns:a="http://schemas.openxmlformats.org/drawingml/2006/main" xmlns:r="http://schemas.openxmlformats.org/officeDocument/2006/relationships" xmlns:p="http://schemas.openxmlformats.org/presentationml/2006/main">
+  <p:cSld>
+    <p:spTree>
+      <p:nvGrpSpPr>
+        <p:cNvPr id="1" name=""/>
+        <p:cNvGrpSpPr/>
+        <p:nvPr/>
+      </p:nvGrpSpPr>
+      <p:grpSpPr>
+        <a:xfrm>
+          <a:off x="0" y="0"/>
+          <a:ext cx="0" cy="0"/>
+          <a:chOff x="0" y="0"/>
+          <a:chExt cx="0" cy="0"/>
+        </a:xfrm>
+      </p:grpSpPr>
+      <p:sp>
+        <p:nvSpPr>
+          <p:cNvPr id="2" name="Slide Image Placeholder 1"/>
+          <p:cNvSpPr>
+            <a:spLocks noGrp="1" noRot="1" noChangeAspect="1"/>
+          </p:cNvSpPr>
+          <p:nvPr>
+            <p:ph type="sldImg"/>
+          </p:nvPr>
+        </p:nvSpPr>
+        <p:spPr/>
+      </p:sp>
+      <p:sp>
+        <p:nvSpPr>
+          <p:cNvPr id="3" name="Notes Placeholder 2"/>
+          <p:cNvSpPr>
+            <a:spLocks noGrp="1"/>
+          </p:cNvSpPr>
+          <p:nvPr>
+            <p:ph type="body" idx="1"/>
+          </p:nvPr>
+        </p:nvSpPr>
+        <p:spPr/>
+        <p:txBody>
+          <a:bodyPr/>
+          <a:lstStyle/>
+          <a:p>
+            <a:r>
+              <a:rPr lang="en-US" dirty="0"/>
+              <a:t/>
+            </a:r>
+            <a:endParaRPr lang="en-US" dirty="0"/>
+          </a:p>
+        </p:txBody>
+      </p:sp>
+      <p:sp>
+        <p:nvSpPr>
+          <p:cNvPr id="4" name="Slide Number Placeholder 3"/>
+          <p:cNvSpPr>
+            <a:spLocks noGrp="1"/>
+          </p:cNvSpPr>
+          <p:nvPr>
+            <p:ph type="sldNum" sz="quarter" idx="10"/>
+          </p:nvPr>
+        </p:nvSpPr>
+        <p:spPr/>
+        <p:txBody>
+          <a:bodyPr/>
+          <a:lstStyle/>
+          <a:p>
+            <a:fld id="{F7021451-1387-4CA6-816F-3879F97B5CBC}" type="slidenum">
+              <a:rPr lang="en-US"/>
+              <a:t>7</a:t>
             </a:fld>
             <a:endParaRPr lang="en-US"/>
           </a:p>
@@ -4899,7 +4988,7 @@
                 <a:ea typeface="Helvetica" pitchFamily="34" charset="-122"/>
                 <a:cs typeface="Helvetica" pitchFamily="34" charset="-120"/>
               </a:rPr>
-              <a:t>YANG ADA DI MENU EXPORT PDF (BUKAN LANGKAH BERURUTAN)</a:t>
+              <a:t>YANG ADA DI MENU EXPORT PDF</a:t>
             </a:r>
             <a:endParaRPr lang="en-US" sz="1250" dirty="0"/>
           </a:p>
@@ -5229,20 +5318,262 @@
           </a:p>
         </p:txBody>
       </p:sp>
-      <p:sp>
-        <p:nvSpPr>
-          <p:cNvPr id="21" name="Shape 19"/>
-          <p:cNvSpPr/>
-          <p:nvPr/>
-        </p:nvSpPr>
-        <p:spPr>
-          <a:xfrm>
-            <a:off x="548640" y="5449507"/>
-            <a:ext cx="11094415" cy="1236853"/>
+    </p:spTree>
+  </p:cSld>
+  <p:clrMapOvr>
+    <a:masterClrMapping/>
+  </p:clrMapOvr>
+</p:sld>
+</file>
+
+<file path=ppt/slides/slide7.xml><?xml version="1.0" encoding="utf-8"?>
+<p:sld xmlns:a="http://schemas.openxmlformats.org/drawingml/2006/main" xmlns:r="http://schemas.openxmlformats.org/officeDocument/2006/relationships" xmlns:p="http://schemas.openxmlformats.org/presentationml/2006/main">
+  <p:cSld name="Slide 7">
+    <p:bg>
+      <p:bgPr>
+        <a:solidFill>
+          <a:srgbClr val="FFFFFF"/>
+        </a:solidFill>
+      </p:bgPr>
+    </p:bg>
+    <p:spTree>
+      <p:nvGrpSpPr>
+        <p:cNvPr id="1" name=""/>
+        <p:cNvGrpSpPr/>
+        <p:nvPr/>
+      </p:nvGrpSpPr>
+      <p:grpSpPr>
+        <a:xfrm>
+          <a:off x="0" y="0"/>
+          <a:ext cx="0" cy="0"/>
+          <a:chOff x="0" y="0"/>
+          <a:chExt cx="0" cy="0"/>
+        </a:xfrm>
+      </p:grpSpPr>
+      <p:sp>
+        <p:nvSpPr>
+          <p:cNvPr id="2" name="Shape 0"/>
+          <p:cNvSpPr/>
+          <p:nvPr/>
+        </p:nvSpPr>
+        <p:spPr>
+          <a:xfrm>
+            <a:off x="0" y="0"/>
+            <a:ext cx="12191695" cy="960120"/>
+          </a:xfrm>
+          <a:prstGeom prst="rect">
+            <a:avLst/>
+          </a:prstGeom>
+          <a:solidFill>
+            <a:srgbClr val="0D1321"/>
+          </a:solidFill>
+          <a:ln/>
+        </p:spPr>
+      </p:sp>
+      <p:sp>
+        <p:nvSpPr>
+          <p:cNvPr id="3" name="Shape 1"/>
+          <p:cNvSpPr/>
+          <p:nvPr/>
+        </p:nvSpPr>
+        <p:spPr>
+          <a:xfrm>
+            <a:off x="0" y="960120"/>
+            <a:ext cx="12191695" cy="41148"/>
+          </a:xfrm>
+          <a:prstGeom prst="rect">
+            <a:avLst/>
+          </a:prstGeom>
+          <a:solidFill>
+            <a:srgbClr val="6849F6"/>
+          </a:solidFill>
+          <a:ln/>
+        </p:spPr>
+      </p:sp>
+      <p:sp>
+        <p:nvSpPr>
+          <p:cNvPr id="4" name="Text 2"/>
+          <p:cNvSpPr/>
+          <p:nvPr/>
+        </p:nvSpPr>
+        <p:spPr>
+          <a:xfrm>
+            <a:off x="502920" y="256032"/>
+            <a:ext cx="3657600" cy="457200"/>
+          </a:xfrm>
+          <a:prstGeom prst="rect">
+            <a:avLst/>
+          </a:prstGeom>
+          <a:noFill/>
+          <a:ln/>
+        </p:spPr>
+        <p:txBody>
+          <a:bodyPr wrap="square" lIns="0" tIns="0" rIns="0" bIns="0" rtlCol="0" anchor="ctr"/>
+          <a:lstStyle/>
+          <a:p>
+            <a:pPr indent="0" marL="0">
+              <a:buNone/>
+            </a:pPr>
+            <a:r>
+              <a:rPr lang="en-US" sz="2000" b="1" dirty="0">
+                <a:solidFill>
+                  <a:srgbClr val="FFFFFF"/>
+                </a:solidFill>
+                <a:latin typeface="Helvetica" pitchFamily="34" charset="0"/>
+                <a:ea typeface="Helvetica" pitchFamily="34" charset="-122"/>
+                <a:cs typeface="Helvetica" pitchFamily="34" charset="-120"/>
+              </a:rPr>
+              <a:t>belajar</a:t>
+            </a:r>
+            <a:pPr indent="0" marL="0">
+              <a:buNone/>
+            </a:pPr>
+            <a:r>
+              <a:rPr lang="en-US" sz="2000" b="1" dirty="0">
+                <a:solidFill>
+                  <a:srgbClr val="8B7CF6"/>
+                </a:solidFill>
+                <a:latin typeface="Helvetica" pitchFamily="34" charset="0"/>
+                <a:ea typeface="Helvetica" pitchFamily="34" charset="-122"/>
+                <a:cs typeface="Helvetica" pitchFamily="34" charset="-120"/>
+              </a:rPr>
+              <a:t>claude</a:t>
+            </a:r>
+            <a:endParaRPr lang="en-US" sz="2000" dirty="0"/>
+          </a:p>
+        </p:txBody>
+      </p:sp>
+      <p:sp>
+        <p:nvSpPr>
+          <p:cNvPr id="5" name="Text 3"/>
+          <p:cNvSpPr/>
+          <p:nvPr/>
+        </p:nvSpPr>
+        <p:spPr>
+          <a:xfrm>
+            <a:off x="5943600" y="274320"/>
+            <a:ext cx="5760720" cy="411480"/>
+          </a:xfrm>
+          <a:prstGeom prst="rect">
+            <a:avLst/>
+          </a:prstGeom>
+          <a:noFill/>
+          <a:ln/>
+        </p:spPr>
+        <p:txBody>
+          <a:bodyPr wrap="square" lIns="0" tIns="0" rIns="0" bIns="0" rtlCol="0" anchor="ctr"/>
+          <a:lstStyle/>
+          <a:p>
+            <a:pPr algn="r" indent="0" marL="0">
+              <a:buNone/>
+            </a:pPr>
+            <a:r>
+              <a:rPr lang="en-US" sz="1250" dirty="0">
+                <a:solidFill>
+                  <a:srgbClr val="9AA2B4"/>
+                </a:solidFill>
+                <a:latin typeface="Helvetica" pitchFamily="34" charset="0"/>
+                <a:ea typeface="Helvetica" pitchFamily="34" charset="-122"/>
+                <a:cs typeface="Helvetica" pitchFamily="34" charset="-120"/>
+              </a:rPr>
+              <a:t>Modul 04 — Spreadsheet &amp; Claude</a:t>
+            </a:r>
+            <a:endParaRPr lang="en-US" sz="1250" dirty="0"/>
+          </a:p>
+        </p:txBody>
+      </p:sp>
+      <p:sp>
+        <p:nvSpPr>
+          <p:cNvPr id="6" name="Text 4"/>
+          <p:cNvSpPr/>
+          <p:nvPr/>
+        </p:nvSpPr>
+        <p:spPr>
+          <a:xfrm>
+            <a:off x="548640" y="1188720"/>
+            <a:ext cx="11064240" cy="502920"/>
+          </a:xfrm>
+          <a:prstGeom prst="rect">
+            <a:avLst/>
+          </a:prstGeom>
+          <a:noFill/>
+          <a:ln/>
+        </p:spPr>
+        <p:txBody>
+          <a:bodyPr wrap="square" lIns="0" tIns="0" rIns="0" bIns="0" rtlCol="0" anchor="ctr"/>
+          <a:lstStyle/>
+          <a:p>
+            <a:pPr indent="0" marL="0">
+              <a:buNone/>
+            </a:pPr>
+            <a:r>
+              <a:rPr lang="en-US" sz="2200" b="1" dirty="0">
+                <a:solidFill>
+                  <a:srgbClr val="0D1321"/>
+                </a:solidFill>
+                <a:latin typeface="Helvetica" pitchFamily="34" charset="0"/>
+                <a:ea typeface="Helvetica" pitchFamily="34" charset="-122"/>
+                <a:cs typeface="Helvetica" pitchFamily="34" charset="-120"/>
+              </a:rPr>
+              <a:t>Tip — Claude di Sheets, Excel Online, &amp; Excel Desktop</a:t>
+            </a:r>
+            <a:endParaRPr lang="en-US" sz="2200" dirty="0"/>
+          </a:p>
+        </p:txBody>
+      </p:sp>
+      <p:sp>
+        <p:nvSpPr>
+          <p:cNvPr id="7" name="Text 5"/>
+          <p:cNvSpPr/>
+          <p:nvPr/>
+        </p:nvSpPr>
+        <p:spPr>
+          <a:xfrm>
+            <a:off x="548640" y="1783080"/>
+            <a:ext cx="11094415" cy="274320"/>
+          </a:xfrm>
+          <a:prstGeom prst="rect">
+            <a:avLst/>
+          </a:prstGeom>
+          <a:noFill/>
+          <a:ln/>
+        </p:spPr>
+        <p:txBody>
+          <a:bodyPr wrap="square" lIns="0" tIns="0" rIns="0" bIns="0" rtlCol="0" anchor="ctr"/>
+          <a:lstStyle/>
+          <a:p>
+            <a:pPr indent="0" marL="0">
+              <a:buNone/>
+            </a:pPr>
+            <a:r>
+              <a:rPr lang="en-US" sz="1250" b="1" spc="40" kern="0" dirty="0">
+                <a:solidFill>
+                  <a:srgbClr val="4B36C7"/>
+                </a:solidFill>
+                <a:latin typeface="Helvetica" pitchFamily="34" charset="0"/>
+                <a:ea typeface="Helvetica" pitchFamily="34" charset="-122"/>
+                <a:cs typeface="Helvetica" pitchFamily="34" charset="-120"/>
+              </a:rPr>
+              <a:t>DUA TOOL BERBEDA, DUA CARA PAKAI</a:t>
+            </a:r>
+            <a:endParaRPr lang="en-US" sz="1250" dirty="0"/>
+          </a:p>
+        </p:txBody>
+      </p:sp>
+      <p:sp>
+        <p:nvSpPr>
+          <p:cNvPr id="8" name="Shape 6"/>
+          <p:cNvSpPr/>
+          <p:nvPr/>
+        </p:nvSpPr>
+        <p:spPr>
+          <a:xfrm>
+            <a:off x="548640" y="2112264"/>
+            <a:ext cx="11094415" cy="1480376"/>
           </a:xfrm>
           <a:prstGeom prst="roundRect">
             <a:avLst>
-              <a:gd name="adj" fmla="val 7393"/>
+              <a:gd name="adj" fmla="val 6177"/>
             </a:avLst>
           </a:prstGeom>
           <a:solidFill>
@@ -5258,13 +5589,13 @@
       </p:sp>
       <p:sp>
         <p:nvSpPr>
-          <p:cNvPr id="22" name="Text 20"/>
-          <p:cNvSpPr/>
-          <p:nvPr/>
-        </p:nvSpPr>
-        <p:spPr>
-          <a:xfrm>
-            <a:off x="749808" y="5650675"/>
+          <p:cNvPr id="9" name="Text 7"/>
+          <p:cNvSpPr/>
+          <p:nvPr/>
+        </p:nvSpPr>
+        <p:spPr>
+          <a:xfrm>
+            <a:off x="749808" y="2313432"/>
             <a:ext cx="10692079" cy="274320"/>
           </a:xfrm>
           <a:prstGeom prst="rect">
@@ -5289,7 +5620,7 @@
                 <a:ea typeface="Helvetica" pitchFamily="34" charset="-122"/>
                 <a:cs typeface="Helvetica" pitchFamily="34" charset="-120"/>
               </a:rPr>
-              <a:t>◆  TIP — CLAUDE IN CHROME: SPREADSHEET TANPA COPY-PASTE</a:t>
+              <a:t>◆  CLAUDE IN CHROME</a:t>
             </a:r>
             <a:endParaRPr lang="en-US" sz="1250" dirty="0"/>
           </a:p>
@@ -5297,14 +5628,14 @@
       </p:sp>
       <p:sp>
         <p:nvSpPr>
-          <p:cNvPr id="23" name="Text 21"/>
-          <p:cNvSpPr/>
-          <p:nvPr/>
-        </p:nvSpPr>
-        <p:spPr>
-          <a:xfrm>
-            <a:off x="749808" y="5998147"/>
-            <a:ext cx="10692079" cy="487045"/>
+          <p:cNvPr id="10" name="Text 8"/>
+          <p:cNvSpPr/>
+          <p:nvPr/>
+        </p:nvSpPr>
+        <p:spPr>
+          <a:xfrm>
+            <a:off x="749808" y="2660904"/>
+            <a:ext cx="10692079" cy="730568"/>
           </a:xfrm>
           <a:prstGeom prst="rect">
             <a:avLst/>
@@ -5331,7 +5662,115 @@
                 <a:ea typeface="Helvetica" pitchFamily="34" charset="-122"/>
                 <a:cs typeface="Helvetica" pitchFamily="34" charset="-120"/>
               </a:rPr>
-              <a:t>Baca &amp; isi formula langsung di Google Sheets (dan Excel Online) tanpa copy-paste. Butuh paket Pro atau lebih tinggi — tidak tersedia di Free. Install "Claude for Chrome" dari Chrome Web Store → login → buka Sheets/Excel Online → klik ikon Claude di toolbar.</a:t>
+              <a:t>Baca &amp; isi formula langsung di Google Sheets atau Excel Online tanpa copy-paste, lewat browser. Butuh paket Pro atau lebih tinggi — tidak tersedia di Free. Install "Claude for Chrome" dari Chrome Web Store → login → buka Sheets/Excel Online → klik ikon Claude di toolbar.</a:t>
+            </a:r>
+            <a:endParaRPr lang="en-US" sz="1250" dirty="0"/>
+          </a:p>
+        </p:txBody>
+      </p:sp>
+      <p:sp>
+        <p:nvSpPr>
+          <p:cNvPr id="11" name="Shape 9"/>
+          <p:cNvSpPr/>
+          <p:nvPr/>
+        </p:nvSpPr>
+        <p:spPr>
+          <a:xfrm>
+            <a:off x="548640" y="3830384"/>
+            <a:ext cx="11094415" cy="1236853"/>
+          </a:xfrm>
+          <a:prstGeom prst="roundRect">
+            <a:avLst>
+              <a:gd name="adj" fmla="val 7393"/>
+            </a:avLst>
+          </a:prstGeom>
+          <a:solidFill>
+            <a:srgbClr val="F3F0FF"/>
+          </a:solidFill>
+          <a:ln w="12700">
+            <a:solidFill>
+              <a:srgbClr val="DCD3FB"/>
+            </a:solidFill>
+            <a:prstDash val="solid"/>
+          </a:ln>
+        </p:spPr>
+      </p:sp>
+      <p:sp>
+        <p:nvSpPr>
+          <p:cNvPr id="12" name="Text 10"/>
+          <p:cNvSpPr/>
+          <p:nvPr/>
+        </p:nvSpPr>
+        <p:spPr>
+          <a:xfrm>
+            <a:off x="749808" y="4031552"/>
+            <a:ext cx="10692079" cy="274320"/>
+          </a:xfrm>
+          <a:prstGeom prst="rect">
+            <a:avLst/>
+          </a:prstGeom>
+          <a:noFill/>
+          <a:ln/>
+        </p:spPr>
+        <p:txBody>
+          <a:bodyPr wrap="square" lIns="0" tIns="0" rIns="0" bIns="0" rtlCol="0" anchor="ctr"/>
+          <a:lstStyle/>
+          <a:p>
+            <a:pPr indent="0" marL="0">
+              <a:buNone/>
+            </a:pPr>
+            <a:r>
+              <a:rPr lang="en-US" sz="1250" b="1" spc="30" kern="0" dirty="0">
+                <a:solidFill>
+                  <a:srgbClr val="4B36C7"/>
+                </a:solidFill>
+                <a:latin typeface="Helvetica" pitchFamily="34" charset="0"/>
+                <a:ea typeface="Helvetica" pitchFamily="34" charset="-122"/>
+                <a:cs typeface="Helvetica" pitchFamily="34" charset="-120"/>
+              </a:rPr>
+              <a:t>◆  CLAUDE FOR EXCEL (EXCEL DESKTOP)</a:t>
+            </a:r>
+            <a:endParaRPr lang="en-US" sz="1250" dirty="0"/>
+          </a:p>
+        </p:txBody>
+      </p:sp>
+      <p:sp>
+        <p:nvSpPr>
+          <p:cNvPr id="13" name="Text 11"/>
+          <p:cNvSpPr/>
+          <p:nvPr/>
+        </p:nvSpPr>
+        <p:spPr>
+          <a:xfrm>
+            <a:off x="749808" y="4379024"/>
+            <a:ext cx="10692079" cy="487045"/>
+          </a:xfrm>
+          <a:prstGeom prst="rect">
+            <a:avLst/>
+          </a:prstGeom>
+          <a:noFill/>
+          <a:ln/>
+        </p:spPr>
+        <p:txBody>
+          <a:bodyPr wrap="square" lIns="0" tIns="0" rIns="0" bIns="0" rtlCol="0" anchor="t"/>
+          <a:lstStyle/>
+          <a:p>
+            <a:pPr indent="0" marL="0">
+              <a:lnSpc>
+                <a:spcPct val="130000"/>
+              </a:lnSpc>
+              <a:buNone/>
+            </a:pPr>
+            <a:r>
+              <a:rPr lang="en-US" sz="1250" dirty="0">
+                <a:solidFill>
+                  <a:srgbClr val="23283A"/>
+                </a:solidFill>
+                <a:latin typeface="Helvetica" pitchFamily="34" charset="0"/>
+                <a:ea typeface="Helvetica" pitchFamily="34" charset="-122"/>
+                <a:cs typeface="Helvetica" pitchFamily="34" charset="-120"/>
+              </a:rPr>
+              <a:t>Pakai Excel Desktop di Windows atau Mac? Ada add-in terpisah bernama "Claude for Excel", diinstall dari Microsoft Marketplace — kerja langsung di dalam Excel, bukan lewat browser. Juga butuh paket Pro atau lebih tinggi.</a:t>
             </a:r>
             <a:endParaRPr lang="en-US" sz="1250" dirty="0"/>
           </a:p>

</xml_diff>

<commit_message>
M4 PPT: sync Bonus slide wording with simplified 2-menu Apps Script (Update Formatting + Export ke PDF)
</commit_message>
<xml_diff>
--- a/K2-Produktivitas/M04-Google-Sheets/K2-M04-Google-Sheets.pptx
+++ b/K2-Produktivitas/M04-Google-Sheets/K2-M04-Google-Sheets.pptx
@@ -4856,11 +4856,11 @@
         <p:spPr>
           <a:xfrm>
             <a:off x="548640" y="2112264"/>
-            <a:ext cx="11094415" cy="1480376"/>
+            <a:ext cx="11094415" cy="1723898"/>
           </a:xfrm>
           <a:prstGeom prst="roundRect">
             <a:avLst>
-              <a:gd name="adj" fmla="val 6177"/>
+              <a:gd name="adj" fmla="val 5304"/>
             </a:avLst>
           </a:prstGeom>
           <a:solidFill>
@@ -4922,7 +4922,7 @@
         <p:spPr>
           <a:xfrm>
             <a:off x="749808" y="2660904"/>
-            <a:ext cx="10692079" cy="730568"/>
+            <a:ext cx="10692079" cy="974090"/>
           </a:xfrm>
           <a:prstGeom prst="rect">
             <a:avLst/>
@@ -4949,7 +4949,7 @@
                 <a:ea typeface="Helvetica" pitchFamily="34" charset="-122"/>
                 <a:cs typeface="Helvetica" pitchFamily="34" charset="-120"/>
               </a:rPr>
-              <a:t>Google Apps Script yang menambahkan menu “Export PDF” ke Sheets-mu: rapikan angka jadi format Rupiah, tambah judul laporan, buat grafik kolom ringkas, lalu export sheet aktif atau rentang terpilih jadi PDF rapi ke Drive. Dibuat dengan memprompt Claude langsung — tidak ada API key atau paket Pro yang dibutuhkan. Khusus Google Sheets — di Excel, minta Claude tulis versi VBA macro dengan prompt serupa.</a:t>
+              <a:t>Google Apps Script yang menambahkan menu “Export PDF” ke Sheets-mu — cuma 2 klik: “1. Update Formatting” untuk otomatis menambah judul laporan, merapikan kolom Total jadi format Rupiah, dan memberi conditional formatting, lalu “2. Export ke PDF” untuk langsung export sheet aktif jadi PDF rapi ke Drive. Dibuat dengan memprompt Claude langsung — tidak ada API key atau paket Pro yang dibutuhkan. Khusus Google Sheets — di Excel, minta Claude tulis versi VBA macro dengan prompt serupa.</a:t>
             </a:r>
             <a:endParaRPr lang="en-US" sz="1250" dirty="0"/>
           </a:p>
@@ -4963,7 +4963,7 @@
         </p:nvSpPr>
         <p:spPr>
           <a:xfrm>
-            <a:off x="548640" y="3830384"/>
+            <a:off x="548640" y="4073906"/>
             <a:ext cx="11094415" cy="274320"/>
           </a:xfrm>
           <a:prstGeom prst="rect">
@@ -5002,12 +5002,12 @@
         </p:nvSpPr>
         <p:spPr>
           <a:xfrm>
-            <a:off x="548640" y="4159568"/>
-            <a:ext cx="3551834" cy="1052195"/>
+            <a:off x="548640" y="4403090"/>
+            <a:ext cx="5437480" cy="1258253"/>
           </a:xfrm>
           <a:prstGeom prst="roundRect">
             <a:avLst>
-              <a:gd name="adj" fmla="val 8690"/>
+              <a:gd name="adj" fmla="val 7267"/>
             </a:avLst>
           </a:prstGeom>
           <a:solidFill>
@@ -5029,8 +5029,8 @@
         </p:nvSpPr>
         <p:spPr>
           <a:xfrm>
-            <a:off x="713232" y="4324160"/>
-            <a:ext cx="3222650" cy="256032"/>
+            <a:off x="713232" y="4567682"/>
+            <a:ext cx="5108296" cy="256032"/>
           </a:xfrm>
           <a:prstGeom prst="rect">
             <a:avLst/>
@@ -5054,7 +5054,7 @@
                 <a:ea typeface="Helvetica" pitchFamily="34" charset="-122"/>
                 <a:cs typeface="Helvetica" pitchFamily="34" charset="-120"/>
               </a:rPr>
-              <a:t>Rapikan &amp; Beri Judul</a:t>
+              <a:t>1. Update Formatting</a:t>
             </a:r>
             <a:endParaRPr lang="en-US" sz="1300" dirty="0"/>
           </a:p>
@@ -5068,8 +5068,8 @@
         </p:nvSpPr>
         <p:spPr>
           <a:xfrm>
-            <a:off x="713232" y="4635056"/>
-            <a:ext cx="3222650" cy="412115"/>
+            <a:off x="713232" y="4878578"/>
+            <a:ext cx="5108296" cy="618173"/>
           </a:xfrm>
           <a:prstGeom prst="rect">
             <a:avLst/>
@@ -5096,7 +5096,7 @@
                 <a:ea typeface="Helvetica" pitchFamily="34" charset="-122"/>
                 <a:cs typeface="Helvetica" pitchFamily="34" charset="-120"/>
               </a:rPr>
-              <a:t>Pilih kolom hasil SUMIF → format Rupiah. Pilih data → tambah judul laporan.</a:t>
+              <a:t>Klik sel mana saja di tabel data → otomatis tambah judul laporan, format Rupiah, dan conditional formatting kolom Total. Tidak perlu select range manual.</a:t>
             </a:r>
             <a:endParaRPr lang="en-US" sz="1100" dirty="0"/>
           </a:p>
@@ -5110,12 +5110,12 @@
         </p:nvSpPr>
         <p:spPr>
           <a:xfrm>
-            <a:off x="4319930" y="4159568"/>
-            <a:ext cx="3551834" cy="1052195"/>
+            <a:off x="6205576" y="4403090"/>
+            <a:ext cx="5437480" cy="1258253"/>
           </a:xfrm>
           <a:prstGeom prst="roundRect">
             <a:avLst>
-              <a:gd name="adj" fmla="val 8690"/>
+              <a:gd name="adj" fmla="val 7267"/>
             </a:avLst>
           </a:prstGeom>
           <a:solidFill>
@@ -5137,8 +5137,8 @@
         </p:nvSpPr>
         <p:spPr>
           <a:xfrm>
-            <a:off x="4484522" y="4324160"/>
-            <a:ext cx="3222650" cy="256032"/>
+            <a:off x="6370168" y="4567682"/>
+            <a:ext cx="5108296" cy="256032"/>
           </a:xfrm>
           <a:prstGeom prst="rect">
             <a:avLst/>
@@ -5162,7 +5162,7 @@
                 <a:ea typeface="Helvetica" pitchFamily="34" charset="-122"/>
                 <a:cs typeface="Helvetica" pitchFamily="34" charset="-120"/>
               </a:rPr>
-              <a:t>Buat Grafik</a:t>
+              <a:t>2. Export ke PDF</a:t>
             </a:r>
             <a:endParaRPr lang="en-US" sz="1300" dirty="0"/>
           </a:p>
@@ -5176,8 +5176,8 @@
         </p:nvSpPr>
         <p:spPr>
           <a:xfrm>
-            <a:off x="4484522" y="4635056"/>
-            <a:ext cx="3222650" cy="412115"/>
+            <a:off x="6370168" y="4878578"/>
+            <a:ext cx="5108296" cy="618173"/>
           </a:xfrm>
           <a:prstGeom prst="rect">
             <a:avLst/>
@@ -5204,115 +5204,7 @@
                 <a:ea typeface="Helvetica" pitchFamily="34" charset="-122"/>
                 <a:cs typeface="Helvetica" pitchFamily="34" charset="-120"/>
               </a:rPr>
-              <a:t>Pilih Nama Produk + Total Revenue → Buat Grafik Ringkas.</a:t>
-            </a:r>
-            <a:endParaRPr lang="en-US" sz="1100" dirty="0"/>
-          </a:p>
-        </p:txBody>
-      </p:sp>
-      <p:sp>
-        <p:nvSpPr>
-          <p:cNvPr id="18" name="Shape 16"/>
-          <p:cNvSpPr/>
-          <p:nvPr/>
-        </p:nvSpPr>
-        <p:spPr>
-          <a:xfrm>
-            <a:off x="8091221" y="4159568"/>
-            <a:ext cx="3551834" cy="1052195"/>
-          </a:xfrm>
-          <a:prstGeom prst="roundRect">
-            <a:avLst>
-              <a:gd name="adj" fmla="val 8690"/>
-            </a:avLst>
-          </a:prstGeom>
-          <a:solidFill>
-            <a:srgbClr val="FFFFFF"/>
-          </a:solidFill>
-          <a:ln w="12700">
-            <a:solidFill>
-              <a:srgbClr val="D6DCEB"/>
-            </a:solidFill>
-            <a:prstDash val="solid"/>
-          </a:ln>
-        </p:spPr>
-      </p:sp>
-      <p:sp>
-        <p:nvSpPr>
-          <p:cNvPr id="19" name="Text 17"/>
-          <p:cNvSpPr/>
-          <p:nvPr/>
-        </p:nvSpPr>
-        <p:spPr>
-          <a:xfrm>
-            <a:off x="8255813" y="4324160"/>
-            <a:ext cx="3222650" cy="256032"/>
-          </a:xfrm>
-          <a:prstGeom prst="rect">
-            <a:avLst/>
-          </a:prstGeom>
-          <a:noFill/>
-          <a:ln/>
-        </p:spPr>
-        <p:txBody>
-          <a:bodyPr wrap="square" lIns="0" tIns="0" rIns="0" bIns="0" rtlCol="0" anchor="ctr"/>
-          <a:lstStyle/>
-          <a:p>
-            <a:pPr indent="0" marL="0">
-              <a:buNone/>
-            </a:pPr>
-            <a:r>
-              <a:rPr lang="en-US" sz="1300" b="1" dirty="0">
-                <a:solidFill>
-                  <a:srgbClr val="0D1321"/>
-                </a:solidFill>
-                <a:latin typeface="Helvetica" pitchFamily="34" charset="0"/>
-                <a:ea typeface="Helvetica" pitchFamily="34" charset="-122"/>
-                <a:cs typeface="Helvetica" pitchFamily="34" charset="-120"/>
-              </a:rPr>
-              <a:t>Export PDF</a:t>
-            </a:r>
-            <a:endParaRPr lang="en-US" sz="1300" dirty="0"/>
-          </a:p>
-        </p:txBody>
-      </p:sp>
-      <p:sp>
-        <p:nvSpPr>
-          <p:cNvPr id="20" name="Text 18"/>
-          <p:cNvSpPr/>
-          <p:nvPr/>
-        </p:nvSpPr>
-        <p:spPr>
-          <a:xfrm>
-            <a:off x="8255813" y="4635056"/>
-            <a:ext cx="3222650" cy="412115"/>
-          </a:xfrm>
-          <a:prstGeom prst="rect">
-            <a:avLst/>
-          </a:prstGeom>
-          <a:noFill/>
-          <a:ln/>
-        </p:spPr>
-        <p:txBody>
-          <a:bodyPr wrap="square" lIns="0" tIns="0" rIns="0" bIns="0" rtlCol="0" anchor="t"/>
-          <a:lstStyle/>
-          <a:p>
-            <a:pPr indent="0" marL="0">
-              <a:lnSpc>
-                <a:spcPct val="125000"/>
-              </a:lnSpc>
-              <a:buNone/>
-            </a:pPr>
-            <a:r>
-              <a:rPr lang="en-US" sz="1100" dirty="0">
-                <a:solidFill>
-                  <a:srgbClr val="6B7280"/>
-                </a:solidFill>
-                <a:latin typeface="Helvetica" pitchFamily="34" charset="0"/>
-                <a:ea typeface="Helvetica" pitchFamily="34" charset="-122"/>
-                <a:cs typeface="Helvetica" pitchFamily="34" charset="-120"/>
-              </a:rPr>
-              <a:t>Jalankan Export — judul, angka rapi, dan grafik ikut ter-export.</a:t>
+              <a:t>Jalankan Export — judul dan formatting dari langkah 1 ikut ter-export karena bagian dari tampilan sheet.</a:t>
             </a:r>
             <a:endParaRPr lang="en-US" sz="1100" dirty="0"/>
           </a:p>

</xml_diff>